<commit_message>
More filled out grad paper presentation
</commit_message>
<xml_diff>
--- a/Grad paper presentation/Dominik Zielinski BME452 Grad Paper Presentation.pptx
+++ b/Grad paper presentation/Dominik Zielinski BME452 Grad Paper Presentation.pptx
@@ -121,6 +121,11 @@
       </a:defRPr>
     </a:lvl9pPr>
   </p:defaultTextStyle>
+  <p:extLst>
+    <p:ext uri="{EFAFB233-063F-42B5-8137-9DF3F51BA10A}">
+      <p15:sldGuideLst xmlns:p15="http://schemas.microsoft.com/office/powerpoint/2012/main"/>
+    </p:ext>
+  </p:extLst>
 </p:presentation>
 </file>
 
@@ -645,6 +650,13 @@
             <a:schemeClr val="lt1"/>
           </a:fontRef>
         </p:style>
+        <p:txBody>
+          <a:bodyPr/>
+          <a:lstStyle/>
+          <a:p>
+            <a:endParaRPr lang="en-US"/>
+          </a:p>
+        </p:txBody>
       </p:sp>
       <p:sp>
         <p:nvSpPr>
@@ -676,6 +688,13 @@
             <a:softEdge rad="0"/>
           </a:effectLst>
         </p:spPr>
+        <p:txBody>
+          <a:bodyPr/>
+          <a:lstStyle/>
+          <a:p>
+            <a:endParaRPr lang="en-US"/>
+          </a:p>
+        </p:txBody>
       </p:sp>
       <p:sp>
         <p:nvSpPr>
@@ -704,6 +723,13 @@
           </a:ln>
           <a:effectLst/>
         </p:spPr>
+        <p:txBody>
+          <a:bodyPr/>
+          <a:lstStyle/>
+          <a:p>
+            <a:endParaRPr lang="en-US"/>
+          </a:p>
+        </p:txBody>
       </p:sp>
       <p:sp>
         <p:nvSpPr>
@@ -742,6 +768,13 @@
             <a:schemeClr val="lt1"/>
           </a:fontRef>
         </p:style>
+        <p:txBody>
+          <a:bodyPr/>
+          <a:lstStyle/>
+          <a:p>
+            <a:endParaRPr lang="en-US"/>
+          </a:p>
+        </p:txBody>
       </p:sp>
       <p:grpSp>
         <p:nvGrpSpPr>
@@ -4069,6 +4102,13 @@
             <a:softEdge rad="0"/>
           </a:effectLst>
         </p:spPr>
+        <p:txBody>
+          <a:bodyPr/>
+          <a:lstStyle/>
+          <a:p>
+            <a:endParaRPr lang="en-US"/>
+          </a:p>
+        </p:txBody>
       </p:sp>
       <p:sp>
         <p:nvSpPr>
@@ -5249,7 +5289,7 @@
         </p:nvSpPr>
         <p:spPr>
           <a:xfrm>
-            <a:off x="2410358" y="6509009"/>
+            <a:off x="2387842" y="6540292"/>
             <a:ext cx="7371281" cy="467706"/>
           </a:xfrm>
           <a:prstGeom prst="rect">
@@ -5488,7 +5528,7 @@
             </a:pPr>
             <a:r>
               <a:rPr lang="en-US" dirty="0"/>
-              <a:t>H-index values taken from google scholar</a:t>
+              <a:t>Various leading experts from the field of robotic exoskeletons</a:t>
             </a:r>
           </a:p>
         </p:txBody>
@@ -6427,6 +6467,1574 @@
           </a:p>
         </p:txBody>
       </p:sp>
+      <p:pic>
+        <p:nvPicPr>
+          <p:cNvPr id="13" name="Picture 12">
+            <a:extLst>
+              <a:ext uri="{FF2B5EF4-FFF2-40B4-BE49-F238E27FC236}">
+                <a16:creationId xmlns:a16="http://schemas.microsoft.com/office/drawing/2014/main" id="{2FE4F3AD-2CB9-2DC4-AF5F-08F0F7B11B51}"/>
+              </a:ext>
+            </a:extLst>
+          </p:cNvPr>
+          <p:cNvPicPr>
+            <a:picLocks noChangeAspect="1"/>
+          </p:cNvPicPr>
+          <p:nvPr/>
+        </p:nvPicPr>
+        <p:blipFill>
+          <a:blip r:embed="rId9"/>
+          <a:stretch>
+            <a:fillRect/>
+          </a:stretch>
+        </p:blipFill>
+        <p:spPr>
+          <a:xfrm>
+            <a:off x="1000364" y="4620468"/>
+            <a:ext cx="1258414" cy="1184390"/>
+          </a:xfrm>
+          <a:prstGeom prst="rect">
+            <a:avLst/>
+          </a:prstGeom>
+        </p:spPr>
+      </p:pic>
+      <p:sp>
+        <p:nvSpPr>
+          <p:cNvPr id="15" name="Content Placeholder 2">
+            <a:extLst>
+              <a:ext uri="{FF2B5EF4-FFF2-40B4-BE49-F238E27FC236}">
+                <a16:creationId xmlns:a16="http://schemas.microsoft.com/office/drawing/2014/main" id="{F053A620-A5D5-F7D0-17B5-9227A538AE2B}"/>
+              </a:ext>
+            </a:extLst>
+          </p:cNvPr>
+          <p:cNvSpPr txBox="1">
+            <a:spLocks/>
+          </p:cNvSpPr>
+          <p:nvPr/>
+        </p:nvSpPr>
+        <p:spPr>
+          <a:xfrm>
+            <a:off x="673972" y="5760558"/>
+            <a:ext cx="2009467" cy="743566"/>
+          </a:xfrm>
+          <a:prstGeom prst="rect">
+            <a:avLst/>
+          </a:prstGeom>
+        </p:spPr>
+        <p:txBody>
+          <a:bodyPr vert="horz" lIns="91440" tIns="45720" rIns="91440" bIns="45720" rtlCol="0">
+            <a:normAutofit fontScale="92500"/>
+          </a:bodyPr>
+          <a:lstStyle>
+            <a:lvl1pPr marL="182880" indent="-182880" algn="l" defTabSz="914400" rtl="0" eaLnBrk="1" latinLnBrk="0" hangingPunct="1">
+              <a:lnSpc>
+                <a:spcPct val="100000"/>
+              </a:lnSpc>
+              <a:spcBef>
+                <a:spcPts val="900"/>
+              </a:spcBef>
+              <a:spcAft>
+                <a:spcPts val="0"/>
+              </a:spcAft>
+              <a:buClr>
+                <a:schemeClr val="tx1">
+                  <a:lumMod val="85000"/>
+                  <a:lumOff val="15000"/>
+                </a:schemeClr>
+              </a:buClr>
+              <a:buFont typeface="Garamond" pitchFamily="18" charset="0"/>
+              <a:buChar char="◦"/>
+              <a:defRPr sz="1800" kern="1200">
+                <a:solidFill>
+                  <a:schemeClr val="tx1"/>
+                </a:solidFill>
+                <a:latin typeface="+mn-lt"/>
+                <a:ea typeface="+mn-ea"/>
+                <a:cs typeface="+mn-cs"/>
+              </a:defRPr>
+            </a:lvl1pPr>
+            <a:lvl2pPr marL="457200" indent="-182880" algn="l" defTabSz="914400" rtl="0" eaLnBrk="1" latinLnBrk="0" hangingPunct="1">
+              <a:lnSpc>
+                <a:spcPct val="100000"/>
+              </a:lnSpc>
+              <a:spcBef>
+                <a:spcPts val="500"/>
+              </a:spcBef>
+              <a:buClr>
+                <a:schemeClr val="tx1">
+                  <a:lumMod val="85000"/>
+                  <a:lumOff val="15000"/>
+                </a:schemeClr>
+              </a:buClr>
+              <a:buFont typeface="Garamond" pitchFamily="18" charset="0"/>
+              <a:buChar char="◦"/>
+              <a:defRPr sz="1600" kern="1200">
+                <a:solidFill>
+                  <a:schemeClr val="tx1"/>
+                </a:solidFill>
+                <a:latin typeface="+mn-lt"/>
+                <a:ea typeface="+mn-ea"/>
+                <a:cs typeface="+mn-cs"/>
+              </a:defRPr>
+            </a:lvl2pPr>
+            <a:lvl3pPr marL="731520" indent="-182880" algn="l" defTabSz="914400" rtl="0" eaLnBrk="1" latinLnBrk="0" hangingPunct="1">
+              <a:lnSpc>
+                <a:spcPct val="100000"/>
+              </a:lnSpc>
+              <a:spcBef>
+                <a:spcPts val="500"/>
+              </a:spcBef>
+              <a:buClr>
+                <a:schemeClr val="tx1">
+                  <a:lumMod val="85000"/>
+                  <a:lumOff val="15000"/>
+                </a:schemeClr>
+              </a:buClr>
+              <a:buFont typeface="Garamond" pitchFamily="18" charset="0"/>
+              <a:buChar char="◦"/>
+              <a:defRPr sz="1400" kern="1200">
+                <a:solidFill>
+                  <a:schemeClr val="tx1"/>
+                </a:solidFill>
+                <a:latin typeface="+mn-lt"/>
+                <a:ea typeface="+mn-ea"/>
+                <a:cs typeface="+mn-cs"/>
+              </a:defRPr>
+            </a:lvl3pPr>
+            <a:lvl4pPr marL="1005840" indent="-182880" algn="l" defTabSz="914400" rtl="0" eaLnBrk="1" latinLnBrk="0" hangingPunct="1">
+              <a:lnSpc>
+                <a:spcPct val="100000"/>
+              </a:lnSpc>
+              <a:spcBef>
+                <a:spcPts val="500"/>
+              </a:spcBef>
+              <a:buClr>
+                <a:schemeClr val="tx1">
+                  <a:lumMod val="85000"/>
+                  <a:lumOff val="15000"/>
+                </a:schemeClr>
+              </a:buClr>
+              <a:buFont typeface="Garamond" pitchFamily="18" charset="0"/>
+              <a:buChar char="◦"/>
+              <a:defRPr sz="1400" kern="1200">
+                <a:solidFill>
+                  <a:schemeClr val="tx1"/>
+                </a:solidFill>
+                <a:latin typeface="+mn-lt"/>
+                <a:ea typeface="+mn-ea"/>
+                <a:cs typeface="+mn-cs"/>
+              </a:defRPr>
+            </a:lvl4pPr>
+            <a:lvl5pPr marL="1280160" indent="-182880" algn="l" defTabSz="914400" rtl="0" eaLnBrk="1" latinLnBrk="0" hangingPunct="1">
+              <a:lnSpc>
+                <a:spcPct val="100000"/>
+              </a:lnSpc>
+              <a:spcBef>
+                <a:spcPts val="500"/>
+              </a:spcBef>
+              <a:buClr>
+                <a:schemeClr val="tx1">
+                  <a:lumMod val="85000"/>
+                  <a:lumOff val="15000"/>
+                </a:schemeClr>
+              </a:buClr>
+              <a:buFont typeface="Garamond" pitchFamily="18" charset="0"/>
+              <a:buChar char="◦"/>
+              <a:defRPr sz="1400" kern="1200">
+                <a:solidFill>
+                  <a:schemeClr val="tx1"/>
+                </a:solidFill>
+                <a:latin typeface="+mn-lt"/>
+                <a:ea typeface="+mn-ea"/>
+                <a:cs typeface="+mn-cs"/>
+              </a:defRPr>
+            </a:lvl5pPr>
+            <a:lvl6pPr marL="1600000" indent="-228600" algn="l" defTabSz="914400" rtl="0" eaLnBrk="1" latinLnBrk="0" hangingPunct="1">
+              <a:lnSpc>
+                <a:spcPct val="100000"/>
+              </a:lnSpc>
+              <a:spcBef>
+                <a:spcPts val="500"/>
+              </a:spcBef>
+              <a:buClr>
+                <a:schemeClr val="tx1">
+                  <a:lumMod val="85000"/>
+                  <a:lumOff val="15000"/>
+                </a:schemeClr>
+              </a:buClr>
+              <a:buFont typeface="Garamond" pitchFamily="18" charset="0"/>
+              <a:buChar char="◦"/>
+              <a:defRPr sz="1400" kern="1200">
+                <a:solidFill>
+                  <a:schemeClr val="tx1"/>
+                </a:solidFill>
+                <a:latin typeface="+mn-lt"/>
+                <a:ea typeface="+mn-ea"/>
+                <a:cs typeface="+mn-cs"/>
+              </a:defRPr>
+            </a:lvl6pPr>
+            <a:lvl7pPr marL="1900000" indent="-228600" algn="l" defTabSz="914400" rtl="0" eaLnBrk="1" latinLnBrk="0" hangingPunct="1">
+              <a:lnSpc>
+                <a:spcPct val="100000"/>
+              </a:lnSpc>
+              <a:spcBef>
+                <a:spcPts val="500"/>
+              </a:spcBef>
+              <a:buClr>
+                <a:schemeClr val="tx1">
+                  <a:lumMod val="85000"/>
+                  <a:lumOff val="15000"/>
+                </a:schemeClr>
+              </a:buClr>
+              <a:buFont typeface="Garamond" pitchFamily="18" charset="0"/>
+              <a:buChar char="◦"/>
+              <a:defRPr sz="1400" kern="1200">
+                <a:solidFill>
+                  <a:schemeClr val="tx1"/>
+                </a:solidFill>
+                <a:latin typeface="+mn-lt"/>
+                <a:ea typeface="+mn-ea"/>
+                <a:cs typeface="+mn-cs"/>
+              </a:defRPr>
+            </a:lvl7pPr>
+            <a:lvl8pPr marL="2200000" indent="-228600" algn="l" defTabSz="914400" rtl="0" eaLnBrk="1" latinLnBrk="0" hangingPunct="1">
+              <a:lnSpc>
+                <a:spcPct val="100000"/>
+              </a:lnSpc>
+              <a:spcBef>
+                <a:spcPts val="500"/>
+              </a:spcBef>
+              <a:buClr>
+                <a:schemeClr val="tx1">
+                  <a:lumMod val="85000"/>
+                  <a:lumOff val="15000"/>
+                </a:schemeClr>
+              </a:buClr>
+              <a:buFont typeface="Garamond" pitchFamily="18" charset="0"/>
+              <a:buChar char="◦"/>
+              <a:defRPr sz="1400" kern="1200">
+                <a:solidFill>
+                  <a:schemeClr val="tx1"/>
+                </a:solidFill>
+                <a:latin typeface="+mn-lt"/>
+                <a:ea typeface="+mn-ea"/>
+                <a:cs typeface="+mn-cs"/>
+              </a:defRPr>
+            </a:lvl8pPr>
+            <a:lvl9pPr marL="2500000" indent="-228600" algn="l" defTabSz="914400" rtl="0" eaLnBrk="1" latinLnBrk="0" hangingPunct="1">
+              <a:lnSpc>
+                <a:spcPct val="100000"/>
+              </a:lnSpc>
+              <a:spcBef>
+                <a:spcPts val="500"/>
+              </a:spcBef>
+              <a:buClr>
+                <a:schemeClr val="tx1">
+                  <a:lumMod val="85000"/>
+                  <a:lumOff val="15000"/>
+                </a:schemeClr>
+              </a:buClr>
+              <a:buFont typeface="Garamond" pitchFamily="18" charset="0"/>
+              <a:buChar char="◦"/>
+              <a:defRPr sz="1400" kern="1200">
+                <a:solidFill>
+                  <a:schemeClr val="tx1"/>
+                </a:solidFill>
+                <a:latin typeface="+mn-lt"/>
+                <a:ea typeface="+mn-ea"/>
+                <a:cs typeface="+mn-cs"/>
+              </a:defRPr>
+            </a:lvl9pPr>
+          </a:lstStyle>
+          <a:p>
+            <a:pPr marL="0" indent="0" algn="ctr">
+              <a:buFont typeface="Garamond" pitchFamily="18" charset="0"/>
+              <a:buNone/>
+            </a:pPr>
+            <a:r>
+              <a:rPr lang="en-US" sz="1600" dirty="0"/>
+              <a:t>Massimo Sartori</a:t>
+            </a:r>
+          </a:p>
+          <a:p>
+            <a:pPr marL="0" indent="0" algn="ctr">
+              <a:buFont typeface="Garamond" pitchFamily="18" charset="0"/>
+              <a:buNone/>
+            </a:pPr>
+            <a:r>
+              <a:rPr lang="en-US" sz="1600" dirty="0"/>
+              <a:t>University of Twente</a:t>
+            </a:r>
+          </a:p>
+        </p:txBody>
+      </p:sp>
+      <p:pic>
+        <p:nvPicPr>
+          <p:cNvPr id="1028" name="Picture 4" descr="Gregory S. Sawicki">
+            <a:extLst>
+              <a:ext uri="{FF2B5EF4-FFF2-40B4-BE49-F238E27FC236}">
+                <a16:creationId xmlns:a16="http://schemas.microsoft.com/office/drawing/2014/main" id="{5712797D-60CB-BF52-812C-B517B29571EB}"/>
+              </a:ext>
+            </a:extLst>
+          </p:cNvPr>
+          <p:cNvPicPr>
+            <a:picLocks noChangeAspect="1" noChangeArrowheads="1"/>
+          </p:cNvPicPr>
+          <p:nvPr/>
+        </p:nvPicPr>
+        <p:blipFill>
+          <a:blip r:embed="rId10">
+            <a:extLst>
+              <a:ext uri="{28A0092B-C50C-407E-A947-70E740481C1C}">
+                <a14:useLocalDpi xmlns:a14="http://schemas.microsoft.com/office/drawing/2010/main" val="0"/>
+              </a:ext>
+            </a:extLst>
+          </a:blip>
+          <a:srcRect/>
+          <a:stretch>
+            <a:fillRect/>
+          </a:stretch>
+        </p:blipFill>
+        <p:spPr bwMode="auto">
+          <a:xfrm>
+            <a:off x="3312880" y="4659443"/>
+            <a:ext cx="1110997" cy="1119745"/>
+          </a:xfrm>
+          <a:prstGeom prst="rect">
+            <a:avLst/>
+          </a:prstGeom>
+          <a:noFill/>
+          <a:extLst>
+            <a:ext uri="{909E8E84-426E-40DD-AFC4-6F175D3DCCD1}">
+              <a14:hiddenFill xmlns:a14="http://schemas.microsoft.com/office/drawing/2010/main">
+                <a:solidFill>
+                  <a:srgbClr val="FFFFFF"/>
+                </a:solidFill>
+              </a14:hiddenFill>
+            </a:ext>
+          </a:extLst>
+        </p:spPr>
+      </p:pic>
+      <p:sp>
+        <p:nvSpPr>
+          <p:cNvPr id="16" name="Content Placeholder 2">
+            <a:extLst>
+              <a:ext uri="{FF2B5EF4-FFF2-40B4-BE49-F238E27FC236}">
+                <a16:creationId xmlns:a16="http://schemas.microsoft.com/office/drawing/2014/main" id="{1DB7FAF8-0DA4-7476-16E5-D2897884DF9A}"/>
+              </a:ext>
+            </a:extLst>
+          </p:cNvPr>
+          <p:cNvSpPr txBox="1">
+            <a:spLocks/>
+          </p:cNvSpPr>
+          <p:nvPr/>
+        </p:nvSpPr>
+        <p:spPr>
+          <a:xfrm>
+            <a:off x="2896759" y="5760558"/>
+            <a:ext cx="2009467" cy="743566"/>
+          </a:xfrm>
+          <a:prstGeom prst="rect">
+            <a:avLst/>
+          </a:prstGeom>
+        </p:spPr>
+        <p:txBody>
+          <a:bodyPr vert="horz" lIns="91440" tIns="45720" rIns="91440" bIns="45720" rtlCol="0">
+            <a:normAutofit/>
+          </a:bodyPr>
+          <a:lstStyle>
+            <a:lvl1pPr marL="182880" indent="-182880" algn="l" defTabSz="914400" rtl="0" eaLnBrk="1" latinLnBrk="0" hangingPunct="1">
+              <a:lnSpc>
+                <a:spcPct val="100000"/>
+              </a:lnSpc>
+              <a:spcBef>
+                <a:spcPts val="900"/>
+              </a:spcBef>
+              <a:spcAft>
+                <a:spcPts val="0"/>
+              </a:spcAft>
+              <a:buClr>
+                <a:schemeClr val="tx1">
+                  <a:lumMod val="85000"/>
+                  <a:lumOff val="15000"/>
+                </a:schemeClr>
+              </a:buClr>
+              <a:buFont typeface="Garamond" pitchFamily="18" charset="0"/>
+              <a:buChar char="◦"/>
+              <a:defRPr sz="1800" kern="1200">
+                <a:solidFill>
+                  <a:schemeClr val="tx1"/>
+                </a:solidFill>
+                <a:latin typeface="+mn-lt"/>
+                <a:ea typeface="+mn-ea"/>
+                <a:cs typeface="+mn-cs"/>
+              </a:defRPr>
+            </a:lvl1pPr>
+            <a:lvl2pPr marL="457200" indent="-182880" algn="l" defTabSz="914400" rtl="0" eaLnBrk="1" latinLnBrk="0" hangingPunct="1">
+              <a:lnSpc>
+                <a:spcPct val="100000"/>
+              </a:lnSpc>
+              <a:spcBef>
+                <a:spcPts val="500"/>
+              </a:spcBef>
+              <a:buClr>
+                <a:schemeClr val="tx1">
+                  <a:lumMod val="85000"/>
+                  <a:lumOff val="15000"/>
+                </a:schemeClr>
+              </a:buClr>
+              <a:buFont typeface="Garamond" pitchFamily="18" charset="0"/>
+              <a:buChar char="◦"/>
+              <a:defRPr sz="1600" kern="1200">
+                <a:solidFill>
+                  <a:schemeClr val="tx1"/>
+                </a:solidFill>
+                <a:latin typeface="+mn-lt"/>
+                <a:ea typeface="+mn-ea"/>
+                <a:cs typeface="+mn-cs"/>
+              </a:defRPr>
+            </a:lvl2pPr>
+            <a:lvl3pPr marL="731520" indent="-182880" algn="l" defTabSz="914400" rtl="0" eaLnBrk="1" latinLnBrk="0" hangingPunct="1">
+              <a:lnSpc>
+                <a:spcPct val="100000"/>
+              </a:lnSpc>
+              <a:spcBef>
+                <a:spcPts val="500"/>
+              </a:spcBef>
+              <a:buClr>
+                <a:schemeClr val="tx1">
+                  <a:lumMod val="85000"/>
+                  <a:lumOff val="15000"/>
+                </a:schemeClr>
+              </a:buClr>
+              <a:buFont typeface="Garamond" pitchFamily="18" charset="0"/>
+              <a:buChar char="◦"/>
+              <a:defRPr sz="1400" kern="1200">
+                <a:solidFill>
+                  <a:schemeClr val="tx1"/>
+                </a:solidFill>
+                <a:latin typeface="+mn-lt"/>
+                <a:ea typeface="+mn-ea"/>
+                <a:cs typeface="+mn-cs"/>
+              </a:defRPr>
+            </a:lvl3pPr>
+            <a:lvl4pPr marL="1005840" indent="-182880" algn="l" defTabSz="914400" rtl="0" eaLnBrk="1" latinLnBrk="0" hangingPunct="1">
+              <a:lnSpc>
+                <a:spcPct val="100000"/>
+              </a:lnSpc>
+              <a:spcBef>
+                <a:spcPts val="500"/>
+              </a:spcBef>
+              <a:buClr>
+                <a:schemeClr val="tx1">
+                  <a:lumMod val="85000"/>
+                  <a:lumOff val="15000"/>
+                </a:schemeClr>
+              </a:buClr>
+              <a:buFont typeface="Garamond" pitchFamily="18" charset="0"/>
+              <a:buChar char="◦"/>
+              <a:defRPr sz="1400" kern="1200">
+                <a:solidFill>
+                  <a:schemeClr val="tx1"/>
+                </a:solidFill>
+                <a:latin typeface="+mn-lt"/>
+                <a:ea typeface="+mn-ea"/>
+                <a:cs typeface="+mn-cs"/>
+              </a:defRPr>
+            </a:lvl4pPr>
+            <a:lvl5pPr marL="1280160" indent="-182880" algn="l" defTabSz="914400" rtl="0" eaLnBrk="1" latinLnBrk="0" hangingPunct="1">
+              <a:lnSpc>
+                <a:spcPct val="100000"/>
+              </a:lnSpc>
+              <a:spcBef>
+                <a:spcPts val="500"/>
+              </a:spcBef>
+              <a:buClr>
+                <a:schemeClr val="tx1">
+                  <a:lumMod val="85000"/>
+                  <a:lumOff val="15000"/>
+                </a:schemeClr>
+              </a:buClr>
+              <a:buFont typeface="Garamond" pitchFamily="18" charset="0"/>
+              <a:buChar char="◦"/>
+              <a:defRPr sz="1400" kern="1200">
+                <a:solidFill>
+                  <a:schemeClr val="tx1"/>
+                </a:solidFill>
+                <a:latin typeface="+mn-lt"/>
+                <a:ea typeface="+mn-ea"/>
+                <a:cs typeface="+mn-cs"/>
+              </a:defRPr>
+            </a:lvl5pPr>
+            <a:lvl6pPr marL="1600000" indent="-228600" algn="l" defTabSz="914400" rtl="0" eaLnBrk="1" latinLnBrk="0" hangingPunct="1">
+              <a:lnSpc>
+                <a:spcPct val="100000"/>
+              </a:lnSpc>
+              <a:spcBef>
+                <a:spcPts val="500"/>
+              </a:spcBef>
+              <a:buClr>
+                <a:schemeClr val="tx1">
+                  <a:lumMod val="85000"/>
+                  <a:lumOff val="15000"/>
+                </a:schemeClr>
+              </a:buClr>
+              <a:buFont typeface="Garamond" pitchFamily="18" charset="0"/>
+              <a:buChar char="◦"/>
+              <a:defRPr sz="1400" kern="1200">
+                <a:solidFill>
+                  <a:schemeClr val="tx1"/>
+                </a:solidFill>
+                <a:latin typeface="+mn-lt"/>
+                <a:ea typeface="+mn-ea"/>
+                <a:cs typeface="+mn-cs"/>
+              </a:defRPr>
+            </a:lvl6pPr>
+            <a:lvl7pPr marL="1900000" indent="-228600" algn="l" defTabSz="914400" rtl="0" eaLnBrk="1" latinLnBrk="0" hangingPunct="1">
+              <a:lnSpc>
+                <a:spcPct val="100000"/>
+              </a:lnSpc>
+              <a:spcBef>
+                <a:spcPts val="500"/>
+              </a:spcBef>
+              <a:buClr>
+                <a:schemeClr val="tx1">
+                  <a:lumMod val="85000"/>
+                  <a:lumOff val="15000"/>
+                </a:schemeClr>
+              </a:buClr>
+              <a:buFont typeface="Garamond" pitchFamily="18" charset="0"/>
+              <a:buChar char="◦"/>
+              <a:defRPr sz="1400" kern="1200">
+                <a:solidFill>
+                  <a:schemeClr val="tx1"/>
+                </a:solidFill>
+                <a:latin typeface="+mn-lt"/>
+                <a:ea typeface="+mn-ea"/>
+                <a:cs typeface="+mn-cs"/>
+              </a:defRPr>
+            </a:lvl7pPr>
+            <a:lvl8pPr marL="2200000" indent="-228600" algn="l" defTabSz="914400" rtl="0" eaLnBrk="1" latinLnBrk="0" hangingPunct="1">
+              <a:lnSpc>
+                <a:spcPct val="100000"/>
+              </a:lnSpc>
+              <a:spcBef>
+                <a:spcPts val="500"/>
+              </a:spcBef>
+              <a:buClr>
+                <a:schemeClr val="tx1">
+                  <a:lumMod val="85000"/>
+                  <a:lumOff val="15000"/>
+                </a:schemeClr>
+              </a:buClr>
+              <a:buFont typeface="Garamond" pitchFamily="18" charset="0"/>
+              <a:buChar char="◦"/>
+              <a:defRPr sz="1400" kern="1200">
+                <a:solidFill>
+                  <a:schemeClr val="tx1"/>
+                </a:solidFill>
+                <a:latin typeface="+mn-lt"/>
+                <a:ea typeface="+mn-ea"/>
+                <a:cs typeface="+mn-cs"/>
+              </a:defRPr>
+            </a:lvl8pPr>
+            <a:lvl9pPr marL="2500000" indent="-228600" algn="l" defTabSz="914400" rtl="0" eaLnBrk="1" latinLnBrk="0" hangingPunct="1">
+              <a:lnSpc>
+                <a:spcPct val="100000"/>
+              </a:lnSpc>
+              <a:spcBef>
+                <a:spcPts val="500"/>
+              </a:spcBef>
+              <a:buClr>
+                <a:schemeClr val="tx1">
+                  <a:lumMod val="85000"/>
+                  <a:lumOff val="15000"/>
+                </a:schemeClr>
+              </a:buClr>
+              <a:buFont typeface="Garamond" pitchFamily="18" charset="0"/>
+              <a:buChar char="◦"/>
+              <a:defRPr sz="1400" kern="1200">
+                <a:solidFill>
+                  <a:schemeClr val="tx1"/>
+                </a:solidFill>
+                <a:latin typeface="+mn-lt"/>
+                <a:ea typeface="+mn-ea"/>
+                <a:cs typeface="+mn-cs"/>
+              </a:defRPr>
+            </a:lvl9pPr>
+          </a:lstStyle>
+          <a:p>
+            <a:pPr marL="0" indent="0" algn="ctr">
+              <a:buFont typeface="Garamond" pitchFamily="18" charset="0"/>
+              <a:buNone/>
+            </a:pPr>
+            <a:r>
+              <a:rPr lang="en-US" sz="1600" dirty="0"/>
+              <a:t>Gregory S. Sawicki</a:t>
+            </a:r>
+          </a:p>
+          <a:p>
+            <a:pPr marL="0" indent="0" algn="ctr">
+              <a:buFont typeface="Garamond" pitchFamily="18" charset="0"/>
+              <a:buNone/>
+            </a:pPr>
+            <a:r>
+              <a:rPr lang="en-US" sz="1600" dirty="0"/>
+              <a:t>Georgia Tech</a:t>
+            </a:r>
+          </a:p>
+        </p:txBody>
+      </p:sp>
+      <p:sp>
+        <p:nvSpPr>
+          <p:cNvPr id="17" name="Content Placeholder 2">
+            <a:extLst>
+              <a:ext uri="{FF2B5EF4-FFF2-40B4-BE49-F238E27FC236}">
+                <a16:creationId xmlns:a16="http://schemas.microsoft.com/office/drawing/2014/main" id="{579F5569-435C-11A3-1BA0-0FF94CA82FF1}"/>
+              </a:ext>
+            </a:extLst>
+          </p:cNvPr>
+          <p:cNvSpPr txBox="1">
+            <a:spLocks/>
+          </p:cNvSpPr>
+          <p:nvPr/>
+        </p:nvSpPr>
+        <p:spPr>
+          <a:xfrm>
+            <a:off x="5091264" y="5712405"/>
+            <a:ext cx="2009467" cy="1006002"/>
+          </a:xfrm>
+          <a:prstGeom prst="rect">
+            <a:avLst/>
+          </a:prstGeom>
+        </p:spPr>
+        <p:txBody>
+          <a:bodyPr vert="horz" lIns="91440" tIns="45720" rIns="91440" bIns="45720" rtlCol="0">
+            <a:normAutofit/>
+          </a:bodyPr>
+          <a:lstStyle>
+            <a:lvl1pPr marL="182880" indent="-182880" algn="l" defTabSz="914400" rtl="0" eaLnBrk="1" latinLnBrk="0" hangingPunct="1">
+              <a:lnSpc>
+                <a:spcPct val="100000"/>
+              </a:lnSpc>
+              <a:spcBef>
+                <a:spcPts val="900"/>
+              </a:spcBef>
+              <a:spcAft>
+                <a:spcPts val="0"/>
+              </a:spcAft>
+              <a:buClr>
+                <a:schemeClr val="tx1">
+                  <a:lumMod val="85000"/>
+                  <a:lumOff val="15000"/>
+                </a:schemeClr>
+              </a:buClr>
+              <a:buFont typeface="Garamond" pitchFamily="18" charset="0"/>
+              <a:buChar char="◦"/>
+              <a:defRPr sz="1800" kern="1200">
+                <a:solidFill>
+                  <a:schemeClr val="tx1"/>
+                </a:solidFill>
+                <a:latin typeface="+mn-lt"/>
+                <a:ea typeface="+mn-ea"/>
+                <a:cs typeface="+mn-cs"/>
+              </a:defRPr>
+            </a:lvl1pPr>
+            <a:lvl2pPr marL="457200" indent="-182880" algn="l" defTabSz="914400" rtl="0" eaLnBrk="1" latinLnBrk="0" hangingPunct="1">
+              <a:lnSpc>
+                <a:spcPct val="100000"/>
+              </a:lnSpc>
+              <a:spcBef>
+                <a:spcPts val="500"/>
+              </a:spcBef>
+              <a:buClr>
+                <a:schemeClr val="tx1">
+                  <a:lumMod val="85000"/>
+                  <a:lumOff val="15000"/>
+                </a:schemeClr>
+              </a:buClr>
+              <a:buFont typeface="Garamond" pitchFamily="18" charset="0"/>
+              <a:buChar char="◦"/>
+              <a:defRPr sz="1600" kern="1200">
+                <a:solidFill>
+                  <a:schemeClr val="tx1"/>
+                </a:solidFill>
+                <a:latin typeface="+mn-lt"/>
+                <a:ea typeface="+mn-ea"/>
+                <a:cs typeface="+mn-cs"/>
+              </a:defRPr>
+            </a:lvl2pPr>
+            <a:lvl3pPr marL="731520" indent="-182880" algn="l" defTabSz="914400" rtl="0" eaLnBrk="1" latinLnBrk="0" hangingPunct="1">
+              <a:lnSpc>
+                <a:spcPct val="100000"/>
+              </a:lnSpc>
+              <a:spcBef>
+                <a:spcPts val="500"/>
+              </a:spcBef>
+              <a:buClr>
+                <a:schemeClr val="tx1">
+                  <a:lumMod val="85000"/>
+                  <a:lumOff val="15000"/>
+                </a:schemeClr>
+              </a:buClr>
+              <a:buFont typeface="Garamond" pitchFamily="18" charset="0"/>
+              <a:buChar char="◦"/>
+              <a:defRPr sz="1400" kern="1200">
+                <a:solidFill>
+                  <a:schemeClr val="tx1"/>
+                </a:solidFill>
+                <a:latin typeface="+mn-lt"/>
+                <a:ea typeface="+mn-ea"/>
+                <a:cs typeface="+mn-cs"/>
+              </a:defRPr>
+            </a:lvl3pPr>
+            <a:lvl4pPr marL="1005840" indent="-182880" algn="l" defTabSz="914400" rtl="0" eaLnBrk="1" latinLnBrk="0" hangingPunct="1">
+              <a:lnSpc>
+                <a:spcPct val="100000"/>
+              </a:lnSpc>
+              <a:spcBef>
+                <a:spcPts val="500"/>
+              </a:spcBef>
+              <a:buClr>
+                <a:schemeClr val="tx1">
+                  <a:lumMod val="85000"/>
+                  <a:lumOff val="15000"/>
+                </a:schemeClr>
+              </a:buClr>
+              <a:buFont typeface="Garamond" pitchFamily="18" charset="0"/>
+              <a:buChar char="◦"/>
+              <a:defRPr sz="1400" kern="1200">
+                <a:solidFill>
+                  <a:schemeClr val="tx1"/>
+                </a:solidFill>
+                <a:latin typeface="+mn-lt"/>
+                <a:ea typeface="+mn-ea"/>
+                <a:cs typeface="+mn-cs"/>
+              </a:defRPr>
+            </a:lvl4pPr>
+            <a:lvl5pPr marL="1280160" indent="-182880" algn="l" defTabSz="914400" rtl="0" eaLnBrk="1" latinLnBrk="0" hangingPunct="1">
+              <a:lnSpc>
+                <a:spcPct val="100000"/>
+              </a:lnSpc>
+              <a:spcBef>
+                <a:spcPts val="500"/>
+              </a:spcBef>
+              <a:buClr>
+                <a:schemeClr val="tx1">
+                  <a:lumMod val="85000"/>
+                  <a:lumOff val="15000"/>
+                </a:schemeClr>
+              </a:buClr>
+              <a:buFont typeface="Garamond" pitchFamily="18" charset="0"/>
+              <a:buChar char="◦"/>
+              <a:defRPr sz="1400" kern="1200">
+                <a:solidFill>
+                  <a:schemeClr val="tx1"/>
+                </a:solidFill>
+                <a:latin typeface="+mn-lt"/>
+                <a:ea typeface="+mn-ea"/>
+                <a:cs typeface="+mn-cs"/>
+              </a:defRPr>
+            </a:lvl5pPr>
+            <a:lvl6pPr marL="1600000" indent="-228600" algn="l" defTabSz="914400" rtl="0" eaLnBrk="1" latinLnBrk="0" hangingPunct="1">
+              <a:lnSpc>
+                <a:spcPct val="100000"/>
+              </a:lnSpc>
+              <a:spcBef>
+                <a:spcPts val="500"/>
+              </a:spcBef>
+              <a:buClr>
+                <a:schemeClr val="tx1">
+                  <a:lumMod val="85000"/>
+                  <a:lumOff val="15000"/>
+                </a:schemeClr>
+              </a:buClr>
+              <a:buFont typeface="Garamond" pitchFamily="18" charset="0"/>
+              <a:buChar char="◦"/>
+              <a:defRPr sz="1400" kern="1200">
+                <a:solidFill>
+                  <a:schemeClr val="tx1"/>
+                </a:solidFill>
+                <a:latin typeface="+mn-lt"/>
+                <a:ea typeface="+mn-ea"/>
+                <a:cs typeface="+mn-cs"/>
+              </a:defRPr>
+            </a:lvl6pPr>
+            <a:lvl7pPr marL="1900000" indent="-228600" algn="l" defTabSz="914400" rtl="0" eaLnBrk="1" latinLnBrk="0" hangingPunct="1">
+              <a:lnSpc>
+                <a:spcPct val="100000"/>
+              </a:lnSpc>
+              <a:spcBef>
+                <a:spcPts val="500"/>
+              </a:spcBef>
+              <a:buClr>
+                <a:schemeClr val="tx1">
+                  <a:lumMod val="85000"/>
+                  <a:lumOff val="15000"/>
+                </a:schemeClr>
+              </a:buClr>
+              <a:buFont typeface="Garamond" pitchFamily="18" charset="0"/>
+              <a:buChar char="◦"/>
+              <a:defRPr sz="1400" kern="1200">
+                <a:solidFill>
+                  <a:schemeClr val="tx1"/>
+                </a:solidFill>
+                <a:latin typeface="+mn-lt"/>
+                <a:ea typeface="+mn-ea"/>
+                <a:cs typeface="+mn-cs"/>
+              </a:defRPr>
+            </a:lvl7pPr>
+            <a:lvl8pPr marL="2200000" indent="-228600" algn="l" defTabSz="914400" rtl="0" eaLnBrk="1" latinLnBrk="0" hangingPunct="1">
+              <a:lnSpc>
+                <a:spcPct val="100000"/>
+              </a:lnSpc>
+              <a:spcBef>
+                <a:spcPts val="500"/>
+              </a:spcBef>
+              <a:buClr>
+                <a:schemeClr val="tx1">
+                  <a:lumMod val="85000"/>
+                  <a:lumOff val="15000"/>
+                </a:schemeClr>
+              </a:buClr>
+              <a:buFont typeface="Garamond" pitchFamily="18" charset="0"/>
+              <a:buChar char="◦"/>
+              <a:defRPr sz="1400" kern="1200">
+                <a:solidFill>
+                  <a:schemeClr val="tx1"/>
+                </a:solidFill>
+                <a:latin typeface="+mn-lt"/>
+                <a:ea typeface="+mn-ea"/>
+                <a:cs typeface="+mn-cs"/>
+              </a:defRPr>
+            </a:lvl8pPr>
+            <a:lvl9pPr marL="2500000" indent="-228600" algn="l" defTabSz="914400" rtl="0" eaLnBrk="1" latinLnBrk="0" hangingPunct="1">
+              <a:lnSpc>
+                <a:spcPct val="100000"/>
+              </a:lnSpc>
+              <a:spcBef>
+                <a:spcPts val="500"/>
+              </a:spcBef>
+              <a:buClr>
+                <a:schemeClr val="tx1">
+                  <a:lumMod val="85000"/>
+                  <a:lumOff val="15000"/>
+                </a:schemeClr>
+              </a:buClr>
+              <a:buFont typeface="Garamond" pitchFamily="18" charset="0"/>
+              <a:buChar char="◦"/>
+              <a:defRPr sz="1400" kern="1200">
+                <a:solidFill>
+                  <a:schemeClr val="tx1"/>
+                </a:solidFill>
+                <a:latin typeface="+mn-lt"/>
+                <a:ea typeface="+mn-ea"/>
+                <a:cs typeface="+mn-cs"/>
+              </a:defRPr>
+            </a:lvl9pPr>
+          </a:lstStyle>
+          <a:p>
+            <a:pPr marL="0" indent="0" algn="ctr">
+              <a:buFont typeface="Garamond" pitchFamily="18" charset="0"/>
+              <a:buNone/>
+            </a:pPr>
+            <a:r>
+              <a:rPr lang="en-US" sz="1600" dirty="0"/>
+              <a:t>Jennie Si</a:t>
+            </a:r>
+          </a:p>
+          <a:p>
+            <a:pPr marL="0" indent="0" algn="ctr">
+              <a:buFont typeface="Garamond" pitchFamily="18" charset="0"/>
+              <a:buNone/>
+            </a:pPr>
+            <a:r>
+              <a:rPr lang="en-US" sz="1600" dirty="0"/>
+              <a:t>Arizona State University</a:t>
+            </a:r>
+          </a:p>
+        </p:txBody>
+      </p:sp>
+      <p:sp>
+        <p:nvSpPr>
+          <p:cNvPr id="18" name="Content Placeholder 2">
+            <a:extLst>
+              <a:ext uri="{FF2B5EF4-FFF2-40B4-BE49-F238E27FC236}">
+                <a16:creationId xmlns:a16="http://schemas.microsoft.com/office/drawing/2014/main" id="{5B81845D-5804-FA39-6DFB-FDBB817A325C}"/>
+              </a:ext>
+            </a:extLst>
+          </p:cNvPr>
+          <p:cNvSpPr txBox="1">
+            <a:spLocks/>
+          </p:cNvSpPr>
+          <p:nvPr/>
+        </p:nvSpPr>
+        <p:spPr>
+          <a:xfrm>
+            <a:off x="7473311" y="5777322"/>
+            <a:ext cx="2009467" cy="743566"/>
+          </a:xfrm>
+          <a:prstGeom prst="rect">
+            <a:avLst/>
+          </a:prstGeom>
+        </p:spPr>
+        <p:txBody>
+          <a:bodyPr vert="horz" lIns="91440" tIns="45720" rIns="91440" bIns="45720" rtlCol="0">
+            <a:normAutofit/>
+          </a:bodyPr>
+          <a:lstStyle>
+            <a:lvl1pPr marL="182880" indent="-182880" algn="l" defTabSz="914400" rtl="0" eaLnBrk="1" latinLnBrk="0" hangingPunct="1">
+              <a:lnSpc>
+                <a:spcPct val="100000"/>
+              </a:lnSpc>
+              <a:spcBef>
+                <a:spcPts val="900"/>
+              </a:spcBef>
+              <a:spcAft>
+                <a:spcPts val="0"/>
+              </a:spcAft>
+              <a:buClr>
+                <a:schemeClr val="tx1">
+                  <a:lumMod val="85000"/>
+                  <a:lumOff val="15000"/>
+                </a:schemeClr>
+              </a:buClr>
+              <a:buFont typeface="Garamond" pitchFamily="18" charset="0"/>
+              <a:buChar char="◦"/>
+              <a:defRPr sz="1800" kern="1200">
+                <a:solidFill>
+                  <a:schemeClr val="tx1"/>
+                </a:solidFill>
+                <a:latin typeface="+mn-lt"/>
+                <a:ea typeface="+mn-ea"/>
+                <a:cs typeface="+mn-cs"/>
+              </a:defRPr>
+            </a:lvl1pPr>
+            <a:lvl2pPr marL="457200" indent="-182880" algn="l" defTabSz="914400" rtl="0" eaLnBrk="1" latinLnBrk="0" hangingPunct="1">
+              <a:lnSpc>
+                <a:spcPct val="100000"/>
+              </a:lnSpc>
+              <a:spcBef>
+                <a:spcPts val="500"/>
+              </a:spcBef>
+              <a:buClr>
+                <a:schemeClr val="tx1">
+                  <a:lumMod val="85000"/>
+                  <a:lumOff val="15000"/>
+                </a:schemeClr>
+              </a:buClr>
+              <a:buFont typeface="Garamond" pitchFamily="18" charset="0"/>
+              <a:buChar char="◦"/>
+              <a:defRPr sz="1600" kern="1200">
+                <a:solidFill>
+                  <a:schemeClr val="tx1"/>
+                </a:solidFill>
+                <a:latin typeface="+mn-lt"/>
+                <a:ea typeface="+mn-ea"/>
+                <a:cs typeface="+mn-cs"/>
+              </a:defRPr>
+            </a:lvl2pPr>
+            <a:lvl3pPr marL="731520" indent="-182880" algn="l" defTabSz="914400" rtl="0" eaLnBrk="1" latinLnBrk="0" hangingPunct="1">
+              <a:lnSpc>
+                <a:spcPct val="100000"/>
+              </a:lnSpc>
+              <a:spcBef>
+                <a:spcPts val="500"/>
+              </a:spcBef>
+              <a:buClr>
+                <a:schemeClr val="tx1">
+                  <a:lumMod val="85000"/>
+                  <a:lumOff val="15000"/>
+                </a:schemeClr>
+              </a:buClr>
+              <a:buFont typeface="Garamond" pitchFamily="18" charset="0"/>
+              <a:buChar char="◦"/>
+              <a:defRPr sz="1400" kern="1200">
+                <a:solidFill>
+                  <a:schemeClr val="tx1"/>
+                </a:solidFill>
+                <a:latin typeface="+mn-lt"/>
+                <a:ea typeface="+mn-ea"/>
+                <a:cs typeface="+mn-cs"/>
+              </a:defRPr>
+            </a:lvl3pPr>
+            <a:lvl4pPr marL="1005840" indent="-182880" algn="l" defTabSz="914400" rtl="0" eaLnBrk="1" latinLnBrk="0" hangingPunct="1">
+              <a:lnSpc>
+                <a:spcPct val="100000"/>
+              </a:lnSpc>
+              <a:spcBef>
+                <a:spcPts val="500"/>
+              </a:spcBef>
+              <a:buClr>
+                <a:schemeClr val="tx1">
+                  <a:lumMod val="85000"/>
+                  <a:lumOff val="15000"/>
+                </a:schemeClr>
+              </a:buClr>
+              <a:buFont typeface="Garamond" pitchFamily="18" charset="0"/>
+              <a:buChar char="◦"/>
+              <a:defRPr sz="1400" kern="1200">
+                <a:solidFill>
+                  <a:schemeClr val="tx1"/>
+                </a:solidFill>
+                <a:latin typeface="+mn-lt"/>
+                <a:ea typeface="+mn-ea"/>
+                <a:cs typeface="+mn-cs"/>
+              </a:defRPr>
+            </a:lvl4pPr>
+            <a:lvl5pPr marL="1280160" indent="-182880" algn="l" defTabSz="914400" rtl="0" eaLnBrk="1" latinLnBrk="0" hangingPunct="1">
+              <a:lnSpc>
+                <a:spcPct val="100000"/>
+              </a:lnSpc>
+              <a:spcBef>
+                <a:spcPts val="500"/>
+              </a:spcBef>
+              <a:buClr>
+                <a:schemeClr val="tx1">
+                  <a:lumMod val="85000"/>
+                  <a:lumOff val="15000"/>
+                </a:schemeClr>
+              </a:buClr>
+              <a:buFont typeface="Garamond" pitchFamily="18" charset="0"/>
+              <a:buChar char="◦"/>
+              <a:defRPr sz="1400" kern="1200">
+                <a:solidFill>
+                  <a:schemeClr val="tx1"/>
+                </a:solidFill>
+                <a:latin typeface="+mn-lt"/>
+                <a:ea typeface="+mn-ea"/>
+                <a:cs typeface="+mn-cs"/>
+              </a:defRPr>
+            </a:lvl5pPr>
+            <a:lvl6pPr marL="1600000" indent="-228600" algn="l" defTabSz="914400" rtl="0" eaLnBrk="1" latinLnBrk="0" hangingPunct="1">
+              <a:lnSpc>
+                <a:spcPct val="100000"/>
+              </a:lnSpc>
+              <a:spcBef>
+                <a:spcPts val="500"/>
+              </a:spcBef>
+              <a:buClr>
+                <a:schemeClr val="tx1">
+                  <a:lumMod val="85000"/>
+                  <a:lumOff val="15000"/>
+                </a:schemeClr>
+              </a:buClr>
+              <a:buFont typeface="Garamond" pitchFamily="18" charset="0"/>
+              <a:buChar char="◦"/>
+              <a:defRPr sz="1400" kern="1200">
+                <a:solidFill>
+                  <a:schemeClr val="tx1"/>
+                </a:solidFill>
+                <a:latin typeface="+mn-lt"/>
+                <a:ea typeface="+mn-ea"/>
+                <a:cs typeface="+mn-cs"/>
+              </a:defRPr>
+            </a:lvl6pPr>
+            <a:lvl7pPr marL="1900000" indent="-228600" algn="l" defTabSz="914400" rtl="0" eaLnBrk="1" latinLnBrk="0" hangingPunct="1">
+              <a:lnSpc>
+                <a:spcPct val="100000"/>
+              </a:lnSpc>
+              <a:spcBef>
+                <a:spcPts val="500"/>
+              </a:spcBef>
+              <a:buClr>
+                <a:schemeClr val="tx1">
+                  <a:lumMod val="85000"/>
+                  <a:lumOff val="15000"/>
+                </a:schemeClr>
+              </a:buClr>
+              <a:buFont typeface="Garamond" pitchFamily="18" charset="0"/>
+              <a:buChar char="◦"/>
+              <a:defRPr sz="1400" kern="1200">
+                <a:solidFill>
+                  <a:schemeClr val="tx1"/>
+                </a:solidFill>
+                <a:latin typeface="+mn-lt"/>
+                <a:ea typeface="+mn-ea"/>
+                <a:cs typeface="+mn-cs"/>
+              </a:defRPr>
+            </a:lvl7pPr>
+            <a:lvl8pPr marL="2200000" indent="-228600" algn="l" defTabSz="914400" rtl="0" eaLnBrk="1" latinLnBrk="0" hangingPunct="1">
+              <a:lnSpc>
+                <a:spcPct val="100000"/>
+              </a:lnSpc>
+              <a:spcBef>
+                <a:spcPts val="500"/>
+              </a:spcBef>
+              <a:buClr>
+                <a:schemeClr val="tx1">
+                  <a:lumMod val="85000"/>
+                  <a:lumOff val="15000"/>
+                </a:schemeClr>
+              </a:buClr>
+              <a:buFont typeface="Garamond" pitchFamily="18" charset="0"/>
+              <a:buChar char="◦"/>
+              <a:defRPr sz="1400" kern="1200">
+                <a:solidFill>
+                  <a:schemeClr val="tx1"/>
+                </a:solidFill>
+                <a:latin typeface="+mn-lt"/>
+                <a:ea typeface="+mn-ea"/>
+                <a:cs typeface="+mn-cs"/>
+              </a:defRPr>
+            </a:lvl8pPr>
+            <a:lvl9pPr marL="2500000" indent="-228600" algn="l" defTabSz="914400" rtl="0" eaLnBrk="1" latinLnBrk="0" hangingPunct="1">
+              <a:lnSpc>
+                <a:spcPct val="100000"/>
+              </a:lnSpc>
+              <a:spcBef>
+                <a:spcPts val="500"/>
+              </a:spcBef>
+              <a:buClr>
+                <a:schemeClr val="tx1">
+                  <a:lumMod val="85000"/>
+                  <a:lumOff val="15000"/>
+                </a:schemeClr>
+              </a:buClr>
+              <a:buFont typeface="Garamond" pitchFamily="18" charset="0"/>
+              <a:buChar char="◦"/>
+              <a:defRPr sz="1400" kern="1200">
+                <a:solidFill>
+                  <a:schemeClr val="tx1"/>
+                </a:solidFill>
+                <a:latin typeface="+mn-lt"/>
+                <a:ea typeface="+mn-ea"/>
+                <a:cs typeface="+mn-cs"/>
+              </a:defRPr>
+            </a:lvl9pPr>
+          </a:lstStyle>
+          <a:p>
+            <a:pPr marL="0" indent="0" algn="ctr">
+              <a:buFont typeface="Garamond" pitchFamily="18" charset="0"/>
+              <a:buNone/>
+            </a:pPr>
+            <a:r>
+              <a:rPr lang="en-US" sz="1600" dirty="0"/>
+              <a:t>Patrick Slade</a:t>
+            </a:r>
+          </a:p>
+          <a:p>
+            <a:pPr marL="0" indent="0" algn="ctr">
+              <a:buFont typeface="Garamond" pitchFamily="18" charset="0"/>
+              <a:buNone/>
+            </a:pPr>
+            <a:r>
+              <a:rPr lang="en-US" sz="1600" dirty="0"/>
+              <a:t>Harvard University</a:t>
+            </a:r>
+          </a:p>
+        </p:txBody>
+      </p:sp>
+      <p:sp>
+        <p:nvSpPr>
+          <p:cNvPr id="19" name="Content Placeholder 2">
+            <a:extLst>
+              <a:ext uri="{FF2B5EF4-FFF2-40B4-BE49-F238E27FC236}">
+                <a16:creationId xmlns:a16="http://schemas.microsoft.com/office/drawing/2014/main" id="{1B291C56-9B49-0E7B-0AB1-9192B96BCA34}"/>
+              </a:ext>
+            </a:extLst>
+          </p:cNvPr>
+          <p:cNvSpPr txBox="1">
+            <a:spLocks/>
+          </p:cNvSpPr>
+          <p:nvPr/>
+        </p:nvSpPr>
+        <p:spPr>
+          <a:xfrm>
+            <a:off x="9695901" y="5737031"/>
+            <a:ext cx="2009467" cy="743566"/>
+          </a:xfrm>
+          <a:prstGeom prst="rect">
+            <a:avLst/>
+          </a:prstGeom>
+        </p:spPr>
+        <p:txBody>
+          <a:bodyPr vert="horz" lIns="91440" tIns="45720" rIns="91440" bIns="45720" rtlCol="0">
+            <a:normAutofit/>
+          </a:bodyPr>
+          <a:lstStyle>
+            <a:lvl1pPr marL="182880" indent="-182880" algn="l" defTabSz="914400" rtl="0" eaLnBrk="1" latinLnBrk="0" hangingPunct="1">
+              <a:lnSpc>
+                <a:spcPct val="100000"/>
+              </a:lnSpc>
+              <a:spcBef>
+                <a:spcPts val="900"/>
+              </a:spcBef>
+              <a:spcAft>
+                <a:spcPts val="0"/>
+              </a:spcAft>
+              <a:buClr>
+                <a:schemeClr val="tx1">
+                  <a:lumMod val="85000"/>
+                  <a:lumOff val="15000"/>
+                </a:schemeClr>
+              </a:buClr>
+              <a:buFont typeface="Garamond" pitchFamily="18" charset="0"/>
+              <a:buChar char="◦"/>
+              <a:defRPr sz="1800" kern="1200">
+                <a:solidFill>
+                  <a:schemeClr val="tx1"/>
+                </a:solidFill>
+                <a:latin typeface="+mn-lt"/>
+                <a:ea typeface="+mn-ea"/>
+                <a:cs typeface="+mn-cs"/>
+              </a:defRPr>
+            </a:lvl1pPr>
+            <a:lvl2pPr marL="457200" indent="-182880" algn="l" defTabSz="914400" rtl="0" eaLnBrk="1" latinLnBrk="0" hangingPunct="1">
+              <a:lnSpc>
+                <a:spcPct val="100000"/>
+              </a:lnSpc>
+              <a:spcBef>
+                <a:spcPts val="500"/>
+              </a:spcBef>
+              <a:buClr>
+                <a:schemeClr val="tx1">
+                  <a:lumMod val="85000"/>
+                  <a:lumOff val="15000"/>
+                </a:schemeClr>
+              </a:buClr>
+              <a:buFont typeface="Garamond" pitchFamily="18" charset="0"/>
+              <a:buChar char="◦"/>
+              <a:defRPr sz="1600" kern="1200">
+                <a:solidFill>
+                  <a:schemeClr val="tx1"/>
+                </a:solidFill>
+                <a:latin typeface="+mn-lt"/>
+                <a:ea typeface="+mn-ea"/>
+                <a:cs typeface="+mn-cs"/>
+              </a:defRPr>
+            </a:lvl2pPr>
+            <a:lvl3pPr marL="731520" indent="-182880" algn="l" defTabSz="914400" rtl="0" eaLnBrk="1" latinLnBrk="0" hangingPunct="1">
+              <a:lnSpc>
+                <a:spcPct val="100000"/>
+              </a:lnSpc>
+              <a:spcBef>
+                <a:spcPts val="500"/>
+              </a:spcBef>
+              <a:buClr>
+                <a:schemeClr val="tx1">
+                  <a:lumMod val="85000"/>
+                  <a:lumOff val="15000"/>
+                </a:schemeClr>
+              </a:buClr>
+              <a:buFont typeface="Garamond" pitchFamily="18" charset="0"/>
+              <a:buChar char="◦"/>
+              <a:defRPr sz="1400" kern="1200">
+                <a:solidFill>
+                  <a:schemeClr val="tx1"/>
+                </a:solidFill>
+                <a:latin typeface="+mn-lt"/>
+                <a:ea typeface="+mn-ea"/>
+                <a:cs typeface="+mn-cs"/>
+              </a:defRPr>
+            </a:lvl3pPr>
+            <a:lvl4pPr marL="1005840" indent="-182880" algn="l" defTabSz="914400" rtl="0" eaLnBrk="1" latinLnBrk="0" hangingPunct="1">
+              <a:lnSpc>
+                <a:spcPct val="100000"/>
+              </a:lnSpc>
+              <a:spcBef>
+                <a:spcPts val="500"/>
+              </a:spcBef>
+              <a:buClr>
+                <a:schemeClr val="tx1">
+                  <a:lumMod val="85000"/>
+                  <a:lumOff val="15000"/>
+                </a:schemeClr>
+              </a:buClr>
+              <a:buFont typeface="Garamond" pitchFamily="18" charset="0"/>
+              <a:buChar char="◦"/>
+              <a:defRPr sz="1400" kern="1200">
+                <a:solidFill>
+                  <a:schemeClr val="tx1"/>
+                </a:solidFill>
+                <a:latin typeface="+mn-lt"/>
+                <a:ea typeface="+mn-ea"/>
+                <a:cs typeface="+mn-cs"/>
+              </a:defRPr>
+            </a:lvl4pPr>
+            <a:lvl5pPr marL="1280160" indent="-182880" algn="l" defTabSz="914400" rtl="0" eaLnBrk="1" latinLnBrk="0" hangingPunct="1">
+              <a:lnSpc>
+                <a:spcPct val="100000"/>
+              </a:lnSpc>
+              <a:spcBef>
+                <a:spcPts val="500"/>
+              </a:spcBef>
+              <a:buClr>
+                <a:schemeClr val="tx1">
+                  <a:lumMod val="85000"/>
+                  <a:lumOff val="15000"/>
+                </a:schemeClr>
+              </a:buClr>
+              <a:buFont typeface="Garamond" pitchFamily="18" charset="0"/>
+              <a:buChar char="◦"/>
+              <a:defRPr sz="1400" kern="1200">
+                <a:solidFill>
+                  <a:schemeClr val="tx1"/>
+                </a:solidFill>
+                <a:latin typeface="+mn-lt"/>
+                <a:ea typeface="+mn-ea"/>
+                <a:cs typeface="+mn-cs"/>
+              </a:defRPr>
+            </a:lvl5pPr>
+            <a:lvl6pPr marL="1600000" indent="-228600" algn="l" defTabSz="914400" rtl="0" eaLnBrk="1" latinLnBrk="0" hangingPunct="1">
+              <a:lnSpc>
+                <a:spcPct val="100000"/>
+              </a:lnSpc>
+              <a:spcBef>
+                <a:spcPts val="500"/>
+              </a:spcBef>
+              <a:buClr>
+                <a:schemeClr val="tx1">
+                  <a:lumMod val="85000"/>
+                  <a:lumOff val="15000"/>
+                </a:schemeClr>
+              </a:buClr>
+              <a:buFont typeface="Garamond" pitchFamily="18" charset="0"/>
+              <a:buChar char="◦"/>
+              <a:defRPr sz="1400" kern="1200">
+                <a:solidFill>
+                  <a:schemeClr val="tx1"/>
+                </a:solidFill>
+                <a:latin typeface="+mn-lt"/>
+                <a:ea typeface="+mn-ea"/>
+                <a:cs typeface="+mn-cs"/>
+              </a:defRPr>
+            </a:lvl6pPr>
+            <a:lvl7pPr marL="1900000" indent="-228600" algn="l" defTabSz="914400" rtl="0" eaLnBrk="1" latinLnBrk="0" hangingPunct="1">
+              <a:lnSpc>
+                <a:spcPct val="100000"/>
+              </a:lnSpc>
+              <a:spcBef>
+                <a:spcPts val="500"/>
+              </a:spcBef>
+              <a:buClr>
+                <a:schemeClr val="tx1">
+                  <a:lumMod val="85000"/>
+                  <a:lumOff val="15000"/>
+                </a:schemeClr>
+              </a:buClr>
+              <a:buFont typeface="Garamond" pitchFamily="18" charset="0"/>
+              <a:buChar char="◦"/>
+              <a:defRPr sz="1400" kern="1200">
+                <a:solidFill>
+                  <a:schemeClr val="tx1"/>
+                </a:solidFill>
+                <a:latin typeface="+mn-lt"/>
+                <a:ea typeface="+mn-ea"/>
+                <a:cs typeface="+mn-cs"/>
+              </a:defRPr>
+            </a:lvl7pPr>
+            <a:lvl8pPr marL="2200000" indent="-228600" algn="l" defTabSz="914400" rtl="0" eaLnBrk="1" latinLnBrk="0" hangingPunct="1">
+              <a:lnSpc>
+                <a:spcPct val="100000"/>
+              </a:lnSpc>
+              <a:spcBef>
+                <a:spcPts val="500"/>
+              </a:spcBef>
+              <a:buClr>
+                <a:schemeClr val="tx1">
+                  <a:lumMod val="85000"/>
+                  <a:lumOff val="15000"/>
+                </a:schemeClr>
+              </a:buClr>
+              <a:buFont typeface="Garamond" pitchFamily="18" charset="0"/>
+              <a:buChar char="◦"/>
+              <a:defRPr sz="1400" kern="1200">
+                <a:solidFill>
+                  <a:schemeClr val="tx1"/>
+                </a:solidFill>
+                <a:latin typeface="+mn-lt"/>
+                <a:ea typeface="+mn-ea"/>
+                <a:cs typeface="+mn-cs"/>
+              </a:defRPr>
+            </a:lvl8pPr>
+            <a:lvl9pPr marL="2500000" indent="-228600" algn="l" defTabSz="914400" rtl="0" eaLnBrk="1" latinLnBrk="0" hangingPunct="1">
+              <a:lnSpc>
+                <a:spcPct val="100000"/>
+              </a:lnSpc>
+              <a:spcBef>
+                <a:spcPts val="500"/>
+              </a:spcBef>
+              <a:buClr>
+                <a:schemeClr val="tx1">
+                  <a:lumMod val="85000"/>
+                  <a:lumOff val="15000"/>
+                </a:schemeClr>
+              </a:buClr>
+              <a:buFont typeface="Garamond" pitchFamily="18" charset="0"/>
+              <a:buChar char="◦"/>
+              <a:defRPr sz="1400" kern="1200">
+                <a:solidFill>
+                  <a:schemeClr val="tx1"/>
+                </a:solidFill>
+                <a:latin typeface="+mn-lt"/>
+                <a:ea typeface="+mn-ea"/>
+                <a:cs typeface="+mn-cs"/>
+              </a:defRPr>
+            </a:lvl9pPr>
+          </a:lstStyle>
+          <a:p>
+            <a:pPr marL="0" indent="0" algn="ctr">
+              <a:buFont typeface="Garamond" pitchFamily="18" charset="0"/>
+              <a:buNone/>
+            </a:pPr>
+            <a:r>
+              <a:rPr lang="en-US" sz="1600" dirty="0"/>
+              <a:t>Aaron J. Young</a:t>
+            </a:r>
+          </a:p>
+          <a:p>
+            <a:pPr marL="0" indent="0" algn="ctr">
+              <a:buFont typeface="Garamond" pitchFamily="18" charset="0"/>
+              <a:buNone/>
+            </a:pPr>
+            <a:r>
+              <a:rPr lang="en-US" sz="1600" dirty="0"/>
+              <a:t>Georgia Tech</a:t>
+            </a:r>
+          </a:p>
+        </p:txBody>
+      </p:sp>
+      <p:pic>
+        <p:nvPicPr>
+          <p:cNvPr id="1030" name="Picture 6" descr="Jennie Si">
+            <a:extLst>
+              <a:ext uri="{FF2B5EF4-FFF2-40B4-BE49-F238E27FC236}">
+                <a16:creationId xmlns:a16="http://schemas.microsoft.com/office/drawing/2014/main" id="{2FA5AF2A-F1DD-DC18-E62B-F5EF78C5C469}"/>
+              </a:ext>
+            </a:extLst>
+          </p:cNvPr>
+          <p:cNvPicPr>
+            <a:picLocks noChangeAspect="1" noChangeArrowheads="1"/>
+          </p:cNvPicPr>
+          <p:nvPr/>
+        </p:nvPicPr>
+        <p:blipFill>
+          <a:blip r:embed="rId11">
+            <a:extLst>
+              <a:ext uri="{28A0092B-C50C-407E-A947-70E740481C1C}">
+                <a14:useLocalDpi xmlns:a14="http://schemas.microsoft.com/office/drawing/2010/main" val="0"/>
+              </a:ext>
+            </a:extLst>
+          </a:blip>
+          <a:srcRect/>
+          <a:stretch>
+            <a:fillRect/>
+          </a:stretch>
+        </p:blipFill>
+        <p:spPr bwMode="auto">
+          <a:xfrm>
+            <a:off x="5477979" y="4520359"/>
+            <a:ext cx="1201786" cy="1206814"/>
+          </a:xfrm>
+          <a:prstGeom prst="rect">
+            <a:avLst/>
+          </a:prstGeom>
+          <a:noFill/>
+          <a:extLst>
+            <a:ext uri="{909E8E84-426E-40DD-AFC4-6F175D3DCCD1}">
+              <a14:hiddenFill xmlns:a14="http://schemas.microsoft.com/office/drawing/2010/main">
+                <a:solidFill>
+                  <a:srgbClr val="FFFFFF"/>
+                </a:solidFill>
+              </a14:hiddenFill>
+            </a:ext>
+          </a:extLst>
+        </p:spPr>
+      </p:pic>
+      <p:pic>
+        <p:nvPicPr>
+          <p:cNvPr id="1032" name="Picture 8" descr="Patrick Slade">
+            <a:extLst>
+              <a:ext uri="{FF2B5EF4-FFF2-40B4-BE49-F238E27FC236}">
+                <a16:creationId xmlns:a16="http://schemas.microsoft.com/office/drawing/2014/main" id="{A7D8FE6A-802E-BF7D-9B30-B455CA106869}"/>
+              </a:ext>
+            </a:extLst>
+          </p:cNvPr>
+          <p:cNvPicPr>
+            <a:picLocks noChangeAspect="1" noChangeArrowheads="1"/>
+          </p:cNvPicPr>
+          <p:nvPr/>
+        </p:nvPicPr>
+        <p:blipFill>
+          <a:blip r:embed="rId12">
+            <a:extLst>
+              <a:ext uri="{28A0092B-C50C-407E-A947-70E740481C1C}">
+                <a14:useLocalDpi xmlns:a14="http://schemas.microsoft.com/office/drawing/2010/main" val="0"/>
+              </a:ext>
+            </a:extLst>
+          </a:blip>
+          <a:srcRect/>
+          <a:stretch>
+            <a:fillRect/>
+          </a:stretch>
+        </p:blipFill>
+        <p:spPr bwMode="auto">
+          <a:xfrm>
+            <a:off x="7868444" y="4564330"/>
+            <a:ext cx="1219200" cy="1219200"/>
+          </a:xfrm>
+          <a:prstGeom prst="rect">
+            <a:avLst/>
+          </a:prstGeom>
+          <a:noFill/>
+          <a:extLst>
+            <a:ext uri="{909E8E84-426E-40DD-AFC4-6F175D3DCCD1}">
+              <a14:hiddenFill xmlns:a14="http://schemas.microsoft.com/office/drawing/2010/main">
+                <a:solidFill>
+                  <a:srgbClr val="FFFFFF"/>
+                </a:solidFill>
+              </a14:hiddenFill>
+            </a:ext>
+          </a:extLst>
+        </p:spPr>
+      </p:pic>
+      <p:pic>
+        <p:nvPicPr>
+          <p:cNvPr id="1036" name="Picture 12" descr="Aaron Young">
+            <a:extLst>
+              <a:ext uri="{FF2B5EF4-FFF2-40B4-BE49-F238E27FC236}">
+                <a16:creationId xmlns:a16="http://schemas.microsoft.com/office/drawing/2014/main" id="{50DF9F5A-BF37-7FE9-3B8A-5620F95B0120}"/>
+              </a:ext>
+            </a:extLst>
+          </p:cNvPr>
+          <p:cNvPicPr>
+            <a:picLocks noChangeAspect="1" noChangeArrowheads="1"/>
+          </p:cNvPicPr>
+          <p:nvPr/>
+        </p:nvPicPr>
+        <p:blipFill rotWithShape="1">
+          <a:blip r:embed="rId13">
+            <a:extLst>
+              <a:ext uri="{28A0092B-C50C-407E-A947-70E740481C1C}">
+                <a14:useLocalDpi xmlns:a14="http://schemas.microsoft.com/office/drawing/2010/main" val="0"/>
+              </a:ext>
+            </a:extLst>
+          </a:blip>
+          <a:srcRect b="18262"/>
+          <a:stretch>
+            <a:fillRect/>
+          </a:stretch>
+        </p:blipFill>
+        <p:spPr bwMode="auto">
+          <a:xfrm>
+            <a:off x="10178868" y="4528162"/>
+            <a:ext cx="990515" cy="1219200"/>
+          </a:xfrm>
+          <a:prstGeom prst="rect">
+            <a:avLst/>
+          </a:prstGeom>
+          <a:noFill/>
+          <a:extLst>
+            <a:ext uri="{909E8E84-426E-40DD-AFC4-6F175D3DCCD1}">
+              <a14:hiddenFill xmlns:a14="http://schemas.microsoft.com/office/drawing/2010/main">
+                <a:solidFill>
+                  <a:srgbClr val="FFFFFF"/>
+                </a:solidFill>
+              </a14:hiddenFill>
+            </a:ext>
+          </a:extLst>
+        </p:spPr>
+      </p:pic>
     </p:spTree>
     <p:extLst>
       <p:ext uri="{BB962C8B-B14F-4D97-AF65-F5344CB8AC3E}">
@@ -6508,15 +8116,79 @@
             <p:ph idx="1"/>
           </p:nvPr>
         </p:nvSpPr>
-        <p:spPr/>
+        <p:spPr>
+          <a:xfrm>
+            <a:off x="1066800" y="2103120"/>
+            <a:ext cx="4407074" cy="3931920"/>
+          </a:xfrm>
+        </p:spPr>
         <p:txBody>
           <a:bodyPr/>
           <a:lstStyle/>
           <a:p>
-            <a:endParaRPr lang="en-US"/>
-          </a:p>
-        </p:txBody>
-      </p:sp>
+            <a:pPr marL="0" indent="0">
+              <a:buNone/>
+            </a:pPr>
+            <a:r>
+              <a:rPr lang="en-US" dirty="0"/>
+              <a:t>Fig 1a</a:t>
+            </a:r>
+          </a:p>
+          <a:p>
+            <a:r>
+              <a:rPr lang="en-US" dirty="0"/>
+              <a:t>Graph</a:t>
+            </a:r>
+          </a:p>
+        </p:txBody>
+      </p:sp>
+      <p:pic>
+        <p:nvPicPr>
+          <p:cNvPr id="2050" name="Picture 2">
+            <a:extLst>
+              <a:ext uri="{FF2B5EF4-FFF2-40B4-BE49-F238E27FC236}">
+                <a16:creationId xmlns:a16="http://schemas.microsoft.com/office/drawing/2014/main" id="{49C54CD9-31D2-7EDC-E4D9-70A478D6486E}"/>
+              </a:ext>
+            </a:extLst>
+          </p:cNvPr>
+          <p:cNvPicPr>
+            <a:picLocks noChangeAspect="1" noChangeArrowheads="1"/>
+          </p:cNvPicPr>
+          <p:nvPr/>
+        </p:nvPicPr>
+        <p:blipFill rotWithShape="1">
+          <a:blip r:embed="rId2">
+            <a:extLst>
+              <a:ext uri="{28A0092B-C50C-407E-A947-70E740481C1C}">
+                <a14:useLocalDpi xmlns:a14="http://schemas.microsoft.com/office/drawing/2010/main" val="0"/>
+              </a:ext>
+            </a:extLst>
+          </a:blip>
+          <a:srcRect r="47397"/>
+          <a:stretch>
+            <a:fillRect/>
+          </a:stretch>
+        </p:blipFill>
+        <p:spPr bwMode="auto">
+          <a:xfrm>
+            <a:off x="5473874" y="1814856"/>
+            <a:ext cx="6413326" cy="4400550"/>
+          </a:xfrm>
+          <a:prstGeom prst="rect">
+            <a:avLst/>
+          </a:prstGeom>
+          <a:noFill/>
+          <a:extLst>
+            <a:ext uri="{909E8E84-426E-40DD-AFC4-6F175D3DCCD1}">
+              <a14:hiddenFill xmlns:a14="http://schemas.microsoft.com/office/drawing/2010/main">
+                <a:solidFill>
+                  <a:srgbClr val="FFFFFF"/>
+                </a:solidFill>
+              </a14:hiddenFill>
+            </a:ext>
+          </a:extLst>
+        </p:spPr>
+      </p:pic>
     </p:spTree>
     <p:extLst>
       <p:ext uri="{BB962C8B-B14F-4D97-AF65-F5344CB8AC3E}">
@@ -6598,10 +8270,69 @@
           <a:bodyPr/>
           <a:lstStyle/>
           <a:p>
-            <a:endParaRPr lang="en-US"/>
-          </a:p>
-        </p:txBody>
-      </p:sp>
+            <a:pPr marL="0" indent="0">
+              <a:buNone/>
+            </a:pPr>
+            <a:r>
+              <a:rPr lang="en-US" dirty="0"/>
+              <a:t>Fig 1b</a:t>
+            </a:r>
+          </a:p>
+          <a:p>
+            <a:r>
+              <a:rPr lang="en-US" dirty="0"/>
+              <a:t>No replication</a:t>
+            </a:r>
+          </a:p>
+        </p:txBody>
+      </p:sp>
+      <p:pic>
+        <p:nvPicPr>
+          <p:cNvPr id="3074" name="Picture 2">
+            <a:extLst>
+              <a:ext uri="{FF2B5EF4-FFF2-40B4-BE49-F238E27FC236}">
+                <a16:creationId xmlns:a16="http://schemas.microsoft.com/office/drawing/2014/main" id="{768B0948-1ACC-DD52-4B29-4CE632E11B3C}"/>
+              </a:ext>
+            </a:extLst>
+          </p:cNvPr>
+          <p:cNvPicPr>
+            <a:picLocks noChangeAspect="1" noChangeArrowheads="1"/>
+          </p:cNvPicPr>
+          <p:nvPr/>
+        </p:nvPicPr>
+        <p:blipFill rotWithShape="1">
+          <a:blip r:embed="rId2">
+            <a:extLst>
+              <a:ext uri="{28A0092B-C50C-407E-A947-70E740481C1C}">
+                <a14:useLocalDpi xmlns:a14="http://schemas.microsoft.com/office/drawing/2010/main" val="0"/>
+              </a:ext>
+            </a:extLst>
+          </a:blip>
+          <a:srcRect l="53733"/>
+          <a:stretch>
+            <a:fillRect/>
+          </a:stretch>
+        </p:blipFill>
+        <p:spPr bwMode="auto">
+          <a:xfrm>
+            <a:off x="6194977" y="1814856"/>
+            <a:ext cx="5640888" cy="4400550"/>
+          </a:xfrm>
+          <a:prstGeom prst="rect">
+            <a:avLst/>
+          </a:prstGeom>
+          <a:noFill/>
+          <a:extLst>
+            <a:ext uri="{909E8E84-426E-40DD-AFC4-6F175D3DCCD1}">
+              <a14:hiddenFill xmlns:a14="http://schemas.microsoft.com/office/drawing/2010/main">
+                <a:solidFill>
+                  <a:srgbClr val="FFFFFF"/>
+                </a:solidFill>
+              </a14:hiddenFill>
+            </a:ext>
+          </a:extLst>
+        </p:spPr>
+      </p:pic>
     </p:spTree>
     <p:extLst>
       <p:ext uri="{BB962C8B-B14F-4D97-AF65-F5344CB8AC3E}">
@@ -6688,10 +8419,40 @@
           <a:bodyPr/>
           <a:lstStyle/>
           <a:p>
-            <a:endParaRPr lang="en-US"/>
-          </a:p>
-        </p:txBody>
-      </p:sp>
+            <a:endParaRPr lang="en-US" dirty="0"/>
+          </a:p>
+        </p:txBody>
+      </p:sp>
+      <p:pic>
+        <p:nvPicPr>
+          <p:cNvPr id="5" name="Picture 4">
+            <a:extLst>
+              <a:ext uri="{FF2B5EF4-FFF2-40B4-BE49-F238E27FC236}">
+                <a16:creationId xmlns:a16="http://schemas.microsoft.com/office/drawing/2014/main" id="{E6C76701-079B-44F6-9AFA-A6A13EA6EC10}"/>
+              </a:ext>
+            </a:extLst>
+          </p:cNvPr>
+          <p:cNvPicPr>
+            <a:picLocks noChangeAspect="1"/>
+          </p:cNvPicPr>
+          <p:nvPr/>
+        </p:nvPicPr>
+        <p:blipFill>
+          <a:blip r:embed="rId2"/>
+          <a:stretch>
+            <a:fillRect/>
+          </a:stretch>
+        </p:blipFill>
+        <p:spPr>
+          <a:xfrm>
+            <a:off x="1259074" y="1985126"/>
+            <a:ext cx="9673851" cy="4167907"/>
+          </a:xfrm>
+          <a:prstGeom prst="rect">
+            <a:avLst/>
+          </a:prstGeom>
+        </p:spPr>
+      </p:pic>
     </p:spTree>
     <p:extLst>
       <p:ext uri="{BB962C8B-B14F-4D97-AF65-F5344CB8AC3E}">
@@ -6768,10 +8529,47 @@
         </p:nvSpPr>
         <p:spPr/>
         <p:txBody>
-          <a:bodyPr/>
+          <a:bodyPr>
+            <a:normAutofit/>
+          </a:bodyPr>
           <a:lstStyle/>
           <a:p>
-            <a:endParaRPr lang="en-US" dirty="0"/>
+            <a:r>
+              <a:rPr lang="en-US" sz="2400" dirty="0"/>
+              <a:t>Sim-to-real transfer for exoskeleton control is a compelling but unsolved problem</a:t>
+            </a:r>
+          </a:p>
+          <a:p>
+            <a:r>
+              <a:rPr lang="en-US" sz="2400" dirty="0"/>
+              <a:t>Extraordinary claims require extraordinary evidence </a:t>
+            </a:r>
+          </a:p>
+          <a:p>
+            <a:pPr lvl="1"/>
+            <a:r>
+              <a:rPr lang="en-US" sz="2000" dirty="0"/>
+              <a:t>And reproducible code</a:t>
+            </a:r>
+          </a:p>
+          <a:p>
+            <a:r>
+              <a:rPr lang="en-US" sz="2400" dirty="0"/>
+              <a:t>A single implausible result in a high-profile journal can mobilize an entire field to respond</a:t>
+            </a:r>
+          </a:p>
+          <a:p>
+            <a:r>
+              <a:rPr lang="en-US" sz="2400" dirty="0"/>
+              <a:t>Transparency and reproducibility aren't optional</a:t>
+            </a:r>
+          </a:p>
+          <a:p>
+            <a:pPr lvl="1"/>
+            <a:r>
+              <a:rPr lang="en-US" sz="2000" dirty="0"/>
+              <a:t>They're what makes a result trustworthy</a:t>
+            </a:r>
           </a:p>
         </p:txBody>
       </p:sp>
@@ -7943,7 +9741,7 @@
             </a:pPr>
             <a:r>
               <a:rPr lang="en-US" sz="2400" dirty="0"/>
-              <a:t>This paper was so good, it spawned a derivative work</a:t>
+              <a:t>These results were so surprising, they motivated a derivative work</a:t>
             </a:r>
           </a:p>
         </p:txBody>

</xml_diff>

<commit_message>
Final version of grad paper presentation
</commit_message>
<xml_diff>
--- a/Grad paper presentation/Dominik Zielinski BME452 Grad Paper Presentation.pptx
+++ b/Grad paper presentation/Dominik Zielinski BME452 Grad Paper Presentation.pptx
@@ -19,8 +19,8 @@
     <p:sldId id="263" r:id="rId10"/>
     <p:sldId id="265" r:id="rId11"/>
     <p:sldId id="266" r:id="rId12"/>
-    <p:sldId id="267" r:id="rId13"/>
-    <p:sldId id="268" r:id="rId14"/>
+    <p:sldId id="268" r:id="rId13"/>
+    <p:sldId id="267" r:id="rId14"/>
     <p:sldId id="269" r:id="rId15"/>
     <p:sldId id="270" r:id="rId16"/>
   </p:sldIdLst>
@@ -211,7 +211,7 @@
           <a:p>
             <a:fld id="{FF40B4A6-7EE6-48D9-92C6-480C2604D850}" type="datetimeFigureOut">
               <a:rPr lang="en-US" smtClean="0"/>
-              <a:t>4/20/2026</a:t>
+              <a:t>4/21/2026</a:t>
             </a:fld>
             <a:endParaRPr lang="en-US"/>
           </a:p>
@@ -1070,7 +1070,7 @@
           <a:p>
             <a:fld id="{55CCBFC5-3969-41AE-86E9-9BED2CC87A87}" type="datetimeFigureOut">
               <a:rPr lang="en-US" smtClean="0"/>
-              <a:t>4/20/2026</a:t>
+              <a:t>4/21/2026</a:t>
             </a:fld>
             <a:endParaRPr lang="en-US"/>
           </a:p>
@@ -1272,7 +1272,7 @@
           <a:p>
             <a:fld id="{55CCBFC5-3969-41AE-86E9-9BED2CC87A87}" type="datetimeFigureOut">
               <a:rPr lang="en-US" smtClean="0"/>
-              <a:t>4/20/2026</a:t>
+              <a:t>4/21/2026</a:t>
             </a:fld>
             <a:endParaRPr lang="en-US"/>
           </a:p>
@@ -1452,7 +1452,7 @@
           <a:p>
             <a:fld id="{55CCBFC5-3969-41AE-86E9-9BED2CC87A87}" type="datetimeFigureOut">
               <a:rPr lang="en-US" smtClean="0"/>
-              <a:t>4/20/2026</a:t>
+              <a:t>4/21/2026</a:t>
             </a:fld>
             <a:endParaRPr lang="en-US"/>
           </a:p>
@@ -1622,7 +1622,7 @@
           <a:p>
             <a:fld id="{55CCBFC5-3969-41AE-86E9-9BED2CC87A87}" type="datetimeFigureOut">
               <a:rPr lang="en-US" smtClean="0"/>
-              <a:t>4/20/2026</a:t>
+              <a:t>4/21/2026</a:t>
             </a:fld>
             <a:endParaRPr lang="en-US"/>
           </a:p>
@@ -2193,7 +2193,7 @@
           <a:p>
             <a:fld id="{55CCBFC5-3969-41AE-86E9-9BED2CC87A87}" type="datetimeFigureOut">
               <a:rPr lang="en-US" smtClean="0"/>
-              <a:t>4/20/2026</a:t>
+              <a:t>4/21/2026</a:t>
             </a:fld>
             <a:endParaRPr lang="en-US"/>
           </a:p>
@@ -2495,7 +2495,7 @@
           <a:p>
             <a:fld id="{55CCBFC5-3969-41AE-86E9-9BED2CC87A87}" type="datetimeFigureOut">
               <a:rPr lang="en-US" smtClean="0"/>
-              <a:t>4/20/2026</a:t>
+              <a:t>4/21/2026</a:t>
             </a:fld>
             <a:endParaRPr lang="en-US"/>
           </a:p>
@@ -2932,7 +2932,7 @@
           <a:p>
             <a:fld id="{55CCBFC5-3969-41AE-86E9-9BED2CC87A87}" type="datetimeFigureOut">
               <a:rPr lang="en-US" smtClean="0"/>
-              <a:t>4/20/2026</a:t>
+              <a:t>4/21/2026</a:t>
             </a:fld>
             <a:endParaRPr lang="en-US"/>
           </a:p>
@@ -3050,7 +3050,7 @@
           <a:p>
             <a:fld id="{55CCBFC5-3969-41AE-86E9-9BED2CC87A87}" type="datetimeFigureOut">
               <a:rPr lang="en-US" smtClean="0"/>
-              <a:t>4/20/2026</a:t>
+              <a:t>4/21/2026</a:t>
             </a:fld>
             <a:endParaRPr lang="en-US"/>
           </a:p>
@@ -3145,7 +3145,7 @@
           <a:p>
             <a:fld id="{55CCBFC5-3969-41AE-86E9-9BED2CC87A87}" type="datetimeFigureOut">
               <a:rPr lang="en-US" smtClean="0"/>
-              <a:t>4/20/2026</a:t>
+              <a:t>4/21/2026</a:t>
             </a:fld>
             <a:endParaRPr lang="en-US"/>
           </a:p>
@@ -3527,7 +3527,7 @@
           <a:p>
             <a:fld id="{55CCBFC5-3969-41AE-86E9-9BED2CC87A87}" type="datetimeFigureOut">
               <a:rPr lang="en-US" smtClean="0"/>
-              <a:t>4/20/2026</a:t>
+              <a:t>4/21/2026</a:t>
             </a:fld>
             <a:endParaRPr lang="en-US"/>
           </a:p>
@@ -3921,7 +3921,7 @@
           <a:p>
             <a:fld id="{55CCBFC5-3969-41AE-86E9-9BED2CC87A87}" type="datetimeFigureOut">
               <a:rPr lang="en-US" smtClean="0"/>
-              <a:t>4/20/2026</a:t>
+              <a:t>4/21/2026</a:t>
             </a:fld>
             <a:endParaRPr lang="en-US"/>
           </a:p>
@@ -4241,7 +4241,7 @@
           <a:p>
             <a:fld id="{55CCBFC5-3969-41AE-86E9-9BED2CC87A87}" type="datetimeFigureOut">
               <a:rPr lang="en-US" smtClean="0"/>
-              <a:t>4/20/2026</a:t>
+              <a:t>4/21/2026</a:t>
             </a:fld>
             <a:endParaRPr lang="en-US"/>
           </a:p>
@@ -8137,8 +8137,24 @@
           <a:p>
             <a:r>
               <a:rPr lang="en-US" dirty="0"/>
-              <a:t>Graph</a:t>
-            </a:r>
+              <a:t>Graph of mechanical work by the exoskeleton vs metabolic reduction</a:t>
+            </a:r>
+          </a:p>
+          <a:p>
+            <a:r>
+              <a:rPr lang="en-US" dirty="0"/>
+              <a:t>Most famous papers are perfectly within a reasonable range</a:t>
+            </a:r>
+          </a:p>
+          <a:p>
+            <a:pPr lvl="1"/>
+            <a:r>
+              <a:rPr lang="en-US" dirty="0"/>
+              <a:t>Experiment-free Exoskeleton Assistance Via Learning In Simulation is not</a:t>
+            </a:r>
+          </a:p>
+          <a:p>
+            <a:endParaRPr lang="en-US" dirty="0"/>
           </a:p>
         </p:txBody>
       </p:sp>
@@ -8224,150 +8240,6 @@
           <p:cNvPr id="2" name="Title 1">
             <a:extLst>
               <a:ext uri="{FF2B5EF4-FFF2-40B4-BE49-F238E27FC236}">
-                <a16:creationId xmlns:a16="http://schemas.microsoft.com/office/drawing/2014/main" id="{069A6F88-88CE-68A3-69C8-1D41198E6F36}"/>
-              </a:ext>
-            </a:extLst>
-          </p:cNvPr>
-          <p:cNvSpPr>
-            <a:spLocks noGrp="1"/>
-          </p:cNvSpPr>
-          <p:nvPr>
-            <p:ph type="title"/>
-          </p:nvPr>
-        </p:nvSpPr>
-        <p:spPr/>
-        <p:txBody>
-          <a:bodyPr>
-            <a:normAutofit fontScale="90000"/>
-          </a:bodyPr>
-          <a:lstStyle/>
-          <a:p>
-            <a:r>
-              <a:rPr lang="en-US" dirty="0"/>
-              <a:t>2: A replication study found nothing</a:t>
-            </a:r>
-          </a:p>
-        </p:txBody>
-      </p:sp>
-      <p:sp>
-        <p:nvSpPr>
-          <p:cNvPr id="3" name="Content Placeholder 2">
-            <a:extLst>
-              <a:ext uri="{FF2B5EF4-FFF2-40B4-BE49-F238E27FC236}">
-                <a16:creationId xmlns:a16="http://schemas.microsoft.com/office/drawing/2014/main" id="{E8DF466F-4EDA-5D3E-E9F2-0A5AE7DAD807}"/>
-              </a:ext>
-            </a:extLst>
-          </p:cNvPr>
-          <p:cNvSpPr>
-            <a:spLocks noGrp="1"/>
-          </p:cNvSpPr>
-          <p:nvPr>
-            <p:ph idx="1"/>
-          </p:nvPr>
-        </p:nvSpPr>
-        <p:spPr/>
-        <p:txBody>
-          <a:bodyPr/>
-          <a:lstStyle/>
-          <a:p>
-            <a:pPr marL="0" indent="0">
-              <a:buNone/>
-            </a:pPr>
-            <a:r>
-              <a:rPr lang="en-US" dirty="0"/>
-              <a:t>Fig 1b</a:t>
-            </a:r>
-          </a:p>
-          <a:p>
-            <a:r>
-              <a:rPr lang="en-US" dirty="0"/>
-              <a:t>No replication</a:t>
-            </a:r>
-          </a:p>
-        </p:txBody>
-      </p:sp>
-      <p:pic>
-        <p:nvPicPr>
-          <p:cNvPr id="3074" name="Picture 2">
-            <a:extLst>
-              <a:ext uri="{FF2B5EF4-FFF2-40B4-BE49-F238E27FC236}">
-                <a16:creationId xmlns:a16="http://schemas.microsoft.com/office/drawing/2014/main" id="{768B0948-1ACC-DD52-4B29-4CE632E11B3C}"/>
-              </a:ext>
-            </a:extLst>
-          </p:cNvPr>
-          <p:cNvPicPr>
-            <a:picLocks noChangeAspect="1" noChangeArrowheads="1"/>
-          </p:cNvPicPr>
-          <p:nvPr/>
-        </p:nvPicPr>
-        <p:blipFill rotWithShape="1">
-          <a:blip r:embed="rId2">
-            <a:extLst>
-              <a:ext uri="{28A0092B-C50C-407E-A947-70E740481C1C}">
-                <a14:useLocalDpi xmlns:a14="http://schemas.microsoft.com/office/drawing/2010/main" val="0"/>
-              </a:ext>
-            </a:extLst>
-          </a:blip>
-          <a:srcRect l="53733"/>
-          <a:stretch>
-            <a:fillRect/>
-          </a:stretch>
-        </p:blipFill>
-        <p:spPr bwMode="auto">
-          <a:xfrm>
-            <a:off x="6194977" y="1814856"/>
-            <a:ext cx="5640888" cy="4400550"/>
-          </a:xfrm>
-          <a:prstGeom prst="rect">
-            <a:avLst/>
-          </a:prstGeom>
-          <a:noFill/>
-          <a:extLst>
-            <a:ext uri="{909E8E84-426E-40DD-AFC4-6F175D3DCCD1}">
-              <a14:hiddenFill xmlns:a14="http://schemas.microsoft.com/office/drawing/2010/main">
-                <a:solidFill>
-                  <a:srgbClr val="FFFFFF"/>
-                </a:solidFill>
-              </a14:hiddenFill>
-            </a:ext>
-          </a:extLst>
-        </p:spPr>
-      </p:pic>
-    </p:spTree>
-    <p:extLst>
-      <p:ext uri="{BB962C8B-B14F-4D97-AF65-F5344CB8AC3E}">
-        <p14:creationId xmlns:p14="http://schemas.microsoft.com/office/powerpoint/2010/main" val="2258857528"/>
-      </p:ext>
-    </p:extLst>
-  </p:cSld>
-  <p:clrMapOvr>
-    <a:masterClrMapping/>
-  </p:clrMapOvr>
-</p:sld>
-</file>
-
-<file path=ppt/slides/slide13.xml><?xml version="1.0" encoding="utf-8"?>
-<p:sld xmlns:a="http://schemas.openxmlformats.org/drawingml/2006/main" xmlns:r="http://schemas.openxmlformats.org/officeDocument/2006/relationships" xmlns:p="http://schemas.openxmlformats.org/presentationml/2006/main">
-  <p:cSld>
-    <p:spTree>
-      <p:nvGrpSpPr>
-        <p:cNvPr id="1" name=""/>
-        <p:cNvGrpSpPr/>
-        <p:nvPr/>
-      </p:nvGrpSpPr>
-      <p:grpSpPr>
-        <a:xfrm>
-          <a:off x="0" y="0"/>
-          <a:ext cx="0" cy="0"/>
-          <a:chOff x="0" y="0"/>
-          <a:chExt cx="0" cy="0"/>
-        </a:xfrm>
-      </p:grpSpPr>
-      <p:sp>
-        <p:nvSpPr>
-          <p:cNvPr id="2" name="Title 1">
-            <a:extLst>
-              <a:ext uri="{FF2B5EF4-FFF2-40B4-BE49-F238E27FC236}">
                 <a16:creationId xmlns:a16="http://schemas.microsoft.com/office/drawing/2014/main" id="{02255ADE-AA4A-E61F-89DB-23CFF7BF110A}"/>
               </a:ext>
             </a:extLst>
@@ -8387,13 +8259,13 @@
         </p:spPr>
         <p:txBody>
           <a:bodyPr>
-            <a:normAutofit fontScale="90000"/>
+            <a:normAutofit/>
           </a:bodyPr>
           <a:lstStyle/>
           <a:p>
             <a:r>
               <a:rPr lang="en-US" dirty="0"/>
-              <a:t>3: The method cannot be reproduced</a:t>
+              <a:t>2: The exact method is unknown</a:t>
             </a:r>
           </a:p>
         </p:txBody>
@@ -8466,6 +8338,197 @@
 </p:sld>
 </file>
 
+<file path=ppt/slides/slide13.xml><?xml version="1.0" encoding="utf-8"?>
+<p:sld xmlns:a="http://schemas.openxmlformats.org/drawingml/2006/main" xmlns:r="http://schemas.openxmlformats.org/officeDocument/2006/relationships" xmlns:p="http://schemas.openxmlformats.org/presentationml/2006/main">
+  <p:cSld>
+    <p:spTree>
+      <p:nvGrpSpPr>
+        <p:cNvPr id="1" name=""/>
+        <p:cNvGrpSpPr/>
+        <p:nvPr/>
+      </p:nvGrpSpPr>
+      <p:grpSpPr>
+        <a:xfrm>
+          <a:off x="0" y="0"/>
+          <a:ext cx="0" cy="0"/>
+          <a:chOff x="0" y="0"/>
+          <a:chExt cx="0" cy="0"/>
+        </a:xfrm>
+      </p:grpSpPr>
+      <p:sp>
+        <p:nvSpPr>
+          <p:cNvPr id="2" name="Title 1">
+            <a:extLst>
+              <a:ext uri="{FF2B5EF4-FFF2-40B4-BE49-F238E27FC236}">
+                <a16:creationId xmlns:a16="http://schemas.microsoft.com/office/drawing/2014/main" id="{069A6F88-88CE-68A3-69C8-1D41198E6F36}"/>
+              </a:ext>
+            </a:extLst>
+          </p:cNvPr>
+          <p:cNvSpPr>
+            <a:spLocks noGrp="1"/>
+          </p:cNvSpPr>
+          <p:nvPr>
+            <p:ph type="title"/>
+          </p:nvPr>
+        </p:nvSpPr>
+        <p:spPr/>
+        <p:txBody>
+          <a:bodyPr>
+            <a:normAutofit fontScale="90000"/>
+          </a:bodyPr>
+          <a:lstStyle/>
+          <a:p>
+            <a:r>
+              <a:rPr lang="en-US" dirty="0"/>
+              <a:t>3: A replication study found nothing</a:t>
+            </a:r>
+          </a:p>
+        </p:txBody>
+      </p:sp>
+      <p:sp>
+        <p:nvSpPr>
+          <p:cNvPr id="3" name="Content Placeholder 2">
+            <a:extLst>
+              <a:ext uri="{FF2B5EF4-FFF2-40B4-BE49-F238E27FC236}">
+                <a16:creationId xmlns:a16="http://schemas.microsoft.com/office/drawing/2014/main" id="{E8DF466F-4EDA-5D3E-E9F2-0A5AE7DAD807}"/>
+              </a:ext>
+            </a:extLst>
+          </p:cNvPr>
+          <p:cNvSpPr>
+            <a:spLocks noGrp="1"/>
+          </p:cNvSpPr>
+          <p:nvPr>
+            <p:ph idx="1"/>
+          </p:nvPr>
+        </p:nvSpPr>
+        <p:spPr>
+          <a:xfrm>
+            <a:off x="1066800" y="2103120"/>
+            <a:ext cx="5128177" cy="3931920"/>
+          </a:xfrm>
+        </p:spPr>
+        <p:txBody>
+          <a:bodyPr/>
+          <a:lstStyle/>
+          <a:p>
+            <a:pPr marL="0" indent="0">
+              <a:buNone/>
+            </a:pPr>
+            <a:r>
+              <a:rPr lang="en-US" dirty="0"/>
+              <a:t>Fig 1b</a:t>
+            </a:r>
+          </a:p>
+          <a:p>
+            <a:pPr marL="0" indent="0">
+              <a:buNone/>
+            </a:pPr>
+            <a:r>
+              <a:rPr lang="en-US" dirty="0"/>
+              <a:t>Performed their own replication of the study</a:t>
+            </a:r>
+          </a:p>
+          <a:p>
+            <a:r>
+              <a:rPr lang="en-US" dirty="0"/>
+              <a:t>Did not have the actual neural network controller from original study</a:t>
+            </a:r>
+          </a:p>
+          <a:p>
+            <a:r>
+              <a:rPr lang="en-US" dirty="0"/>
+              <a:t>Instead, they</a:t>
+            </a:r>
+          </a:p>
+          <a:p>
+            <a:pPr lvl="1"/>
+            <a:r>
+              <a:rPr lang="en-US" dirty="0"/>
+              <a:t>Took the average torque profile of original</a:t>
+            </a:r>
+          </a:p>
+          <a:p>
+            <a:pPr lvl="1"/>
+            <a:r>
+              <a:rPr lang="en-US" dirty="0"/>
+              <a:t>Implemented it in their own hip exoskeleton  under the same treadmill walking conditions</a:t>
+            </a:r>
+          </a:p>
+          <a:p>
+            <a:pPr lvl="1"/>
+            <a:r>
+              <a:rPr lang="en-US" dirty="0"/>
+              <a:t>Tested 10 participants with similar demographics</a:t>
+            </a:r>
+          </a:p>
+          <a:p>
+            <a:r>
+              <a:rPr lang="en-US" dirty="0"/>
+              <a:t>Tested four offset timing variations to account for differences in heel strike</a:t>
+            </a:r>
+          </a:p>
+        </p:txBody>
+      </p:sp>
+      <p:pic>
+        <p:nvPicPr>
+          <p:cNvPr id="3074" name="Picture 2">
+            <a:extLst>
+              <a:ext uri="{FF2B5EF4-FFF2-40B4-BE49-F238E27FC236}">
+                <a16:creationId xmlns:a16="http://schemas.microsoft.com/office/drawing/2014/main" id="{768B0948-1ACC-DD52-4B29-4CE632E11B3C}"/>
+              </a:ext>
+            </a:extLst>
+          </p:cNvPr>
+          <p:cNvPicPr>
+            <a:picLocks noChangeAspect="1" noChangeArrowheads="1"/>
+          </p:cNvPicPr>
+          <p:nvPr/>
+        </p:nvPicPr>
+        <p:blipFill rotWithShape="1">
+          <a:blip r:embed="rId2">
+            <a:extLst>
+              <a:ext uri="{28A0092B-C50C-407E-A947-70E740481C1C}">
+                <a14:useLocalDpi xmlns:a14="http://schemas.microsoft.com/office/drawing/2010/main" val="0"/>
+              </a:ext>
+            </a:extLst>
+          </a:blip>
+          <a:srcRect l="53733"/>
+          <a:stretch>
+            <a:fillRect/>
+          </a:stretch>
+        </p:blipFill>
+        <p:spPr bwMode="auto">
+          <a:xfrm>
+            <a:off x="6194977" y="1814856"/>
+            <a:ext cx="5640888" cy="4400550"/>
+          </a:xfrm>
+          <a:prstGeom prst="rect">
+            <a:avLst/>
+          </a:prstGeom>
+          <a:noFill/>
+          <a:extLst>
+            <a:ext uri="{909E8E84-426E-40DD-AFC4-6F175D3DCCD1}">
+              <a14:hiddenFill xmlns:a14="http://schemas.microsoft.com/office/drawing/2010/main">
+                <a:solidFill>
+                  <a:srgbClr val="FFFFFF"/>
+                </a:solidFill>
+              </a14:hiddenFill>
+            </a:ext>
+          </a:extLst>
+        </p:spPr>
+      </p:pic>
+    </p:spTree>
+    <p:extLst>
+      <p:ext uri="{BB962C8B-B14F-4D97-AF65-F5344CB8AC3E}">
+        <p14:creationId xmlns:p14="http://schemas.microsoft.com/office/powerpoint/2010/main" val="2258857528"/>
+      </p:ext>
+    </p:extLst>
+  </p:cSld>
+  <p:clrMapOvr>
+    <a:masterClrMapping/>
+  </p:clrMapOvr>
+</p:sld>
+</file>
+
 <file path=ppt/slides/slide14.xml><?xml version="1.0" encoding="utf-8"?>
 <p:sld xmlns:a="http://schemas.openxmlformats.org/drawingml/2006/main" xmlns:r="http://schemas.openxmlformats.org/officeDocument/2006/relationships" xmlns:p="http://schemas.openxmlformats.org/presentationml/2006/main">
   <p:cSld>
@@ -8562,13 +8625,6 @@
             <a:r>
               <a:rPr lang="en-US" sz="2400" dirty="0"/>
               <a:t>Transparency and reproducibility aren't optional</a:t>
-            </a:r>
-          </a:p>
-          <a:p>
-            <a:pPr lvl="1"/>
-            <a:r>
-              <a:rPr lang="en-US" sz="2000" dirty="0"/>
-              <a:t>They're what makes a result trustworthy</a:t>
             </a:r>
           </a:p>
         </p:txBody>
@@ -9611,7 +9667,7 @@
           <a:p>
             <a:r>
               <a:rPr lang="en-US" sz="2400" dirty="0"/>
-              <a:t>A controller trained entirely in simulation can transfer directly to real hardware with no human experiments</a:t>
+              <a:t>A controller trained entirely in simulation can transfer directly to real hardware with minimal to no human calibration</a:t>
             </a:r>
           </a:p>
           <a:p>
@@ -9717,7 +9773,7 @@
           <a:p>
             <a:r>
               <a:rPr lang="en-US" sz="2400" dirty="0"/>
-              <a:t>A controller trained entirely in simulation can transfer directly to real hardware with no human experiments</a:t>
+              <a:t>A controller trained entirely in simulation can transfer directly to real hardware with minimal to no human experiments</a:t>
             </a:r>
           </a:p>
           <a:p>
@@ -9741,7 +9797,7 @@
             </a:pPr>
             <a:r>
               <a:rPr lang="en-US" sz="2400" dirty="0"/>
-              <a:t>These results were so surprising, they motivated a derivative work</a:t>
+              <a:t>These results were so good, they motivated a derivative work</a:t>
             </a:r>
           </a:p>
         </p:txBody>

</xml_diff>